<commit_message>
docs: remove tickets and authoring history; one source per fact
- Delete docs/tickets and the per-deck build notes; fix every link to them.
- Remove issue numbers, "this task" wording and author-verification
  paragraphs from docs, exercises, homework, instructor notes and the
  Session 4 slides; docs/verification.md is now the single record.
- SYLLABUS.md is the single source for course facts: README,
  materials/README and docs/course-design.md link to it instead of
  repeating audience, workload, sessions and assessment.
- Regenerate the Session 4 deck after removing its verification slide.

Co-Authored-By: Claude Opus 5.5 <noreply@anthropic.com>
</commit_message>
<xml_diff>
--- a/materials/slides/session-4.pptx
+++ b/materials/slides/session-4.pptx
@@ -38,8 +38,6 @@
     <p:sldId id="286" r:id="rId37"/>
     <p:sldId id="287" r:id="rId38"/>
     <p:sldId id="288" r:id="rId39"/>
-    <p:sldId id="289" r:id="rId40"/>
-    <p:sldId id="290" r:id="rId41"/>
   </p:sldIdLst>
   <p:sldSz cx="12191999" cy="6858000" type="screen4x3"/>
   <p:notesSz cx="6858000" cy="9144000"/>
@@ -3213,7 +3211,7 @@
               </a:defRPr>
             </a:pPr>
             <a:r>
-              <a:t>SOURCE 1 / 23</a:t>
+              <a:t>SOURCE 1 / 22</a:t>
             </a:r>
           </a:p>
         </p:txBody>
@@ -3681,7 +3679,7 @@
               </a:defRPr>
             </a:pPr>
             <a:r>
-              <a:t>SOURCE 9 / 23</a:t>
+              <a:t>SOURCE 9 / 22</a:t>
             </a:r>
           </a:p>
         </p:txBody>
@@ -4282,7 +4280,7 @@
               </a:defRPr>
             </a:pPr>
             <a:r>
-              <a:t>SOURCE 10 / 23</a:t>
+              <a:t>SOURCE 10 / 22</a:t>
             </a:r>
           </a:p>
         </p:txBody>
@@ -4821,7 +4819,7 @@
               </a:defRPr>
             </a:pPr>
             <a:r>
-              <a:t>SOURCE 11 / 23</a:t>
+              <a:t>SOURCE 11 / 22</a:t>
             </a:r>
           </a:p>
         </p:txBody>
@@ -5466,7 +5464,7 @@
               </a:defRPr>
             </a:pPr>
             <a:r>
-              <a:t>SOURCE 11 / 23  ·  CONTINUED 2</a:t>
+              <a:t>SOURCE 11 / 22  ·  CONTINUED 2</a:t>
             </a:r>
           </a:p>
         </p:txBody>
@@ -5738,7 +5736,7 @@
               </a:defRPr>
             </a:pPr>
             <a:r>
-              <a:t>SOURCE 12 / 23</a:t>
+              <a:t>SOURCE 12 / 22</a:t>
             </a:r>
           </a:p>
         </p:txBody>
@@ -6424,7 +6422,7 @@
               </a:defRPr>
             </a:pPr>
             <a:r>
-              <a:t>SOURCE 13 / 23</a:t>
+              <a:t>SOURCE 13 / 22</a:t>
             </a:r>
           </a:p>
         </p:txBody>
@@ -7018,7 +7016,7 @@
               </a:defRPr>
             </a:pPr>
             <a:r>
-              <a:t>SOURCE 13 / 23  ·  CONTINUED 2</a:t>
+              <a:t>SOURCE 13 / 22  ·  CONTINUED 2</a:t>
             </a:r>
           </a:p>
         </p:txBody>
@@ -7309,7 +7307,7 @@
               </a:defRPr>
             </a:pPr>
             <a:r>
-              <a:t>SOURCE 14 / 23</a:t>
+              <a:t>SOURCE 14 / 22</a:t>
             </a:r>
           </a:p>
         </p:txBody>
@@ -7970,7 +7968,7 @@
               </a:defRPr>
             </a:pPr>
             <a:r>
-              <a:t>SOURCE 14 / 23  ·  CONTINUED 2</a:t>
+              <a:t>SOURCE 14 / 22  ·  CONTINUED 2</a:t>
             </a:r>
           </a:p>
         </p:txBody>
@@ -8242,7 +8240,7 @@
               </a:defRPr>
             </a:pPr>
             <a:r>
-              <a:t>SOURCE 15 / 23</a:t>
+              <a:t>SOURCE 15 / 22</a:t>
             </a:r>
           </a:p>
         </p:txBody>
@@ -8878,7 +8876,7 @@
               </a:defRPr>
             </a:pPr>
             <a:r>
-              <a:t>SOURCE 2 / 23</a:t>
+              <a:t>SOURCE 2 / 22</a:t>
             </a:r>
           </a:p>
         </p:txBody>
@@ -9149,7 +9147,7 @@
               </a:defRPr>
             </a:pPr>
             <a:r>
-              <a:t>SOURCE 15 / 23  ·  CONTINUED 2</a:t>
+              <a:t>SOURCE 15 / 22  ·  CONTINUED 2</a:t>
             </a:r>
           </a:p>
         </p:txBody>
@@ -9492,7 +9490,7 @@
               </a:defRPr>
             </a:pPr>
             <a:r>
-              <a:t>SOURCE 16 / 23</a:t>
+              <a:t>SOURCE 16 / 22</a:t>
             </a:r>
           </a:p>
         </p:txBody>
@@ -10153,7 +10151,7 @@
               </a:defRPr>
             </a:pPr>
             <a:r>
-              <a:t>SOURCE 16 / 23  ·  CONTINUED 2</a:t>
+              <a:t>SOURCE 16 / 22  ·  CONTINUED 2</a:t>
             </a:r>
           </a:p>
         </p:txBody>
@@ -10425,7 +10423,7 @@
               </a:defRPr>
             </a:pPr>
             <a:r>
-              <a:t>SOURCE 17 / 23</a:t>
+              <a:t>SOURCE 17 / 22</a:t>
             </a:r>
           </a:p>
         </p:txBody>
@@ -11183,7 +11181,7 @@
               </a:defRPr>
             </a:pPr>
             <a:r>
-              <a:t>SOURCE 17 / 23  ·  CONTINUED 2</a:t>
+              <a:t>SOURCE 17 / 22  ·  CONTINUED 2</a:t>
             </a:r>
           </a:p>
         </p:txBody>
@@ -11553,7 +11551,7 @@
               </a:defRPr>
             </a:pPr>
             <a:r>
-              <a:t>SOURCE 18 / 23</a:t>
+              <a:t>SOURCE 18 / 22</a:t>
             </a:r>
           </a:p>
         </p:txBody>
@@ -12311,7 +12309,7 @@
               </a:defRPr>
             </a:pPr>
             <a:r>
-              <a:t>SOURCE 18 / 23  ·  CONTINUED 2</a:t>
+              <a:t>SOURCE 18 / 22  ·  CONTINUED 2</a:t>
             </a:r>
           </a:p>
         </p:txBody>
@@ -12701,7 +12699,7 @@
               </a:defRPr>
             </a:pPr>
             <a:r>
-              <a:t>SOURCE 19 / 23</a:t>
+              <a:t>SOURCE 19 / 22</a:t>
             </a:r>
           </a:p>
         </p:txBody>
@@ -13277,7 +13275,7 @@
               </a:defRPr>
             </a:pPr>
             <a:r>
-              <a:t>SOURCE 19 / 23  ·  CONTINUED 2</a:t>
+              <a:t>SOURCE 19 / 22  ·  CONTINUED 2</a:t>
             </a:r>
           </a:p>
         </p:txBody>
@@ -13611,7 +13609,7 @@
               </a:defRPr>
             </a:pPr>
             <a:r>
-              <a:t>SOURCE 20 / 23</a:t>
+              <a:t>SOURCE 20 / 22</a:t>
             </a:r>
           </a:p>
         </p:txBody>
@@ -13662,7 +13660,7 @@
                 </a:solidFill>
                 <a:latin typeface="Arial"/>
               </a:rPr>
-              <a:t>What has actually been verified?</a:t>
+              <a:t>Break, then 90 minutes of guided practice</a:t>
             </a:r>
           </a:p>
         </p:txBody>
@@ -13721,6 +13719,58 @@
         <p:spPr>
           <a:xfrm>
             <a:off x="594360" y="1737360"/>
+            <a:ext cx="11003279" cy="428244"/>
+          </a:xfrm>
+          <a:prstGeom prst="rect">
+            <a:avLst/>
+          </a:prstGeom>
+          <a:noFill/>
+        </p:spPr>
+        <p:txBody>
+          <a:bodyPr wrap="none" anchor="t" lIns="88900" rIns="88900" tIns="38100" bIns="38100">
+            <a:noAutofit/>
+          </a:bodyPr>
+          <a:lstStyle/>
+          <a:p>
+            <a:pPr marL="279400" indent="-215900">
+              <a:lnSpc>
+                <a:spcPts val="2772"/>
+              </a:lnSpc>
+              <a:spcBef>
+                <a:spcPts val="0"/>
+              </a:spcBef>
+              <a:spcAft>
+                <a:spcPts val="0"/>
+              </a:spcAft>
+              <a:defRPr sz="2100">
+                <a:solidFill>
+                  <a:srgbClr val="20344A"/>
+                </a:solidFill>
+                <a:latin typeface="Arial"/>
+              </a:defRPr>
+              <a:buChar char="•"/>
+            </a:pPr>
+            <a:r>
+              <a:rPr sz="2100" b="0" i="0">
+                <a:solidFill>
+                  <a:srgbClr val="20344A"/>
+                </a:solidFill>
+                <a:latin typeface="Arial"/>
+              </a:rPr>
+              <a:t>Take a 15-minute break before practice.</a:t>
+            </a:r>
+          </a:p>
+        </p:txBody>
+      </p:sp>
+      <p:sp>
+        <p:nvSpPr>
+          <p:cNvPr id="7" name="content:line-275:0"/>
+          <p:cNvSpPr txBox="1"/>
+          <p:nvPr/>
+        </p:nvSpPr>
+        <p:spPr>
+          <a:xfrm>
+            <a:off x="594360" y="2229612"/>
             <a:ext cx="11003279" cy="780288"/>
           </a:xfrm>
           <a:prstGeom prst="rect">
@@ -13755,21 +13805,29 @@
             <a:r>
               <a:rPr sz="2100" b="0" i="0">
                 <a:solidFill>
-                  <a:srgbClr val="007F82"/>
-                </a:solidFill>
-                <a:latin typeface="Arial"/>
-                <a:hlinkClick r:id="rId2"/>
-              </a:rPr>
-              <a:t>Remote Docker CI run 38876609585</a:t>
-            </a:r>
-            <a:r>
-              <a:rPr sz="2100" b="0" i="0">
-                <a:solidFill>
-                  <a:srgbClr val="20344A"/>
-                </a:solidFill>
-                <a:latin typeface="Arial"/>
-              </a:rPr>
-              <a:t> completed successfully </a:t>
+                  <a:srgbClr val="20344A"/>
+                </a:solidFill>
+                <a:latin typeface="Arial"/>
+              </a:rPr>
+              <a:t>15 minutes: trace uploads, HTTP, </a:t>
+            </a:r>
+            <a:r>
+              <a:rPr sz="2100" b="0" i="0">
+                <a:solidFill>
+                  <a:srgbClr val="20344A"/>
+                </a:solidFill>
+                <a:latin typeface="Courier New"/>
+              </a:rPr>
+              <a:t>stat_core</a:t>
+            </a:r>
+            <a:r>
+              <a:rPr sz="2100" b="0" i="0">
+                <a:solidFill>
+                  <a:srgbClr val="20344A"/>
+                </a:solidFill>
+                <a:latin typeface="Arial"/>
+              </a:rPr>
+              <a:t>, and each caller's </a:t>
             </a:r>
             <a:br/>
             <a:r>
@@ -13779,39 +13837,21 @@
                 </a:solidFill>
                 <a:latin typeface="Arial"/>
               </a:rPr>
-              <a:t>for commit </a:t>
-            </a:r>
-            <a:r>
-              <a:rPr sz="2100" b="0" i="0">
-                <a:solidFill>
-                  <a:srgbClr val="20344A"/>
-                </a:solidFill>
-                <a:latin typeface="Courier New"/>
-              </a:rPr>
-              <a:t>c5fc92a37ec660492c7238f55f88b023a9200775</a:t>
-            </a:r>
-            <a:r>
-              <a:rPr sz="2100" b="0" i="0">
-                <a:solidFill>
-                  <a:srgbClr val="20344A"/>
-                </a:solidFill>
-                <a:latin typeface="Arial"/>
-              </a:rPr>
-              <a:t>.</a:t>
-            </a:r>
-          </a:p>
-        </p:txBody>
-      </p:sp>
-      <p:sp>
-        <p:nvSpPr>
-          <p:cNvPr id="7" name="content:line-275:0"/>
-          <p:cNvSpPr txBox="1"/>
-          <p:nvPr/>
-        </p:nvSpPr>
-        <p:spPr>
-          <a:xfrm>
-            <a:off x="594360" y="2581656"/>
-            <a:ext cx="11003279" cy="1132332"/>
+              <a:t>address.</a:t>
+            </a:r>
+          </a:p>
+        </p:txBody>
+      </p:sp>
+      <p:sp>
+        <p:nvSpPr>
+          <p:cNvPr id="8" name="content:line-276:0"/>
+          <p:cNvSpPr txBox="1"/>
+          <p:nvPr/>
+        </p:nvSpPr>
+        <p:spPr>
+          <a:xfrm>
+            <a:off x="594360" y="3073908"/>
+            <a:ext cx="11003279" cy="780288"/>
           </a:xfrm>
           <a:prstGeom prst="rect">
             <a:avLst/>
@@ -13849,7 +13889,7 @@
                 </a:solidFill>
                 <a:latin typeface="Arial"/>
               </a:rPr>
-              <a:t>Its Docker output comparison job builds real images, checks </a:t>
+              <a:t>20 minutes: launch the supplied stack, upload both CSVs, </a:t>
             </a:r>
             <a:br/>
             <a:r>
@@ -13859,7 +13899,59 @@
                 </a:solidFill>
                 <a:latin typeface="Arial"/>
               </a:rPr>
-              <a:t>readiness and service DNS/HTTP, compares local/container </a:t>
+              <a:t>inspect health and logs.</a:t>
+            </a:r>
+          </a:p>
+        </p:txBody>
+      </p:sp>
+      <p:sp>
+        <p:nvSpPr>
+          <p:cNvPr id="9" name="content:line-277:0"/>
+          <p:cNvSpPr txBox="1"/>
+          <p:nvPr/>
+        </p:nvSpPr>
+        <p:spPr>
+          <a:xfrm>
+            <a:off x="594360" y="3918204"/>
+            <a:ext cx="11003279" cy="780288"/>
+          </a:xfrm>
+          <a:prstGeom prst="rect">
+            <a:avLst/>
+          </a:prstGeom>
+          <a:noFill/>
+        </p:spPr>
+        <p:txBody>
+          <a:bodyPr wrap="none" anchor="t" lIns="88900" rIns="88900" tIns="38100" bIns="38100">
+            <a:noAutofit/>
+          </a:bodyPr>
+          <a:lstStyle/>
+          <a:p>
+            <a:pPr marL="279400" indent="-215900">
+              <a:lnSpc>
+                <a:spcPts val="2772"/>
+              </a:lnSpc>
+              <a:spcBef>
+                <a:spcPts val="0"/>
+              </a:spcBef>
+              <a:spcAft>
+                <a:spcPts val="0"/>
+              </a:spcAft>
+              <a:defRPr sz="2100">
+                <a:solidFill>
+                  <a:srgbClr val="20344A"/>
+                </a:solidFill>
+                <a:latin typeface="Arial"/>
+              </a:defRPr>
+              <a:buChar char="•"/>
+            </a:pPr>
+            <a:r>
+              <a:rPr sz="2100" b="0" i="0">
+                <a:solidFill>
+                  <a:srgbClr val="20344A"/>
+                </a:solidFill>
+                <a:latin typeface="Arial"/>
+              </a:rPr>
+              <a:t>15 minutes: repeat the temporary local address failure and </a:t>
             </a:r>
             <a:br/>
             <a:r>
@@ -13869,21 +13961,21 @@
                 </a:solidFill>
                 <a:latin typeface="Arial"/>
               </a:rPr>
-              <a:t>captures, and compares multipart API results.</a:t>
-            </a:r>
-          </a:p>
-        </p:txBody>
-      </p:sp>
-      <p:sp>
-        <p:nvSpPr>
-          <p:cNvPr id="8" name="content:line-276:0"/>
-          <p:cNvSpPr txBox="1"/>
-          <p:nvPr/>
-        </p:nvSpPr>
-        <p:spPr>
-          <a:xfrm>
-            <a:off x="594360" y="3777996"/>
-            <a:ext cx="11003279" cy="1132332"/>
+              <a:t>recovery; restore a working stack.</a:t>
+            </a:r>
+          </a:p>
+        </p:txBody>
+      </p:sp>
+      <p:sp>
+        <p:nvSpPr>
+          <p:cNvPr id="10" name="content:line-278:0"/>
+          <p:cNvSpPr txBox="1"/>
+          <p:nvPr/>
+        </p:nvSpPr>
+        <p:spPr>
+          <a:xfrm>
+            <a:off x="594360" y="4762500"/>
+            <a:ext cx="11003279" cy="780288"/>
           </a:xfrm>
           <a:prstGeom prst="rect">
             <a:avLst/>
@@ -13921,7 +14013,7 @@
                 </a:solidFill>
                 <a:latin typeface="Arial"/>
               </a:rPr>
-              <a:t>This is evidence for that commit and environment; rerun for </a:t>
+              <a:t>25 minutes: capture twice locally and once in Docker; compare </a:t>
             </a:r>
             <a:br/>
             <a:r>
@@ -13931,50 +14023,21 @@
                 </a:solidFill>
                 <a:latin typeface="Arial"/>
               </a:rPr>
-              <a:t>later changes. The </a:t>
-            </a:r>
-            <a:r>
-              <a:rPr sz="2100" b="0" i="0">
-                <a:solidFill>
-                  <a:srgbClr val="007F82"/>
-                </a:solidFill>
-                <a:latin typeface="Arial"/>
-                <a:hlinkClick r:id="rId3"/>
-              </a:rPr>
-              <a:t>workflow</a:t>
-            </a:r>
-            <a:r>
-              <a:rPr sz="2100" b="0" i="0">
-                <a:solidFill>
-                  <a:srgbClr val="20344A"/>
-                </a:solidFill>
-                <a:latin typeface="Arial"/>
-              </a:rPr>
-              <a:t> retains available evidence for </a:t>
-            </a:r>
-            <a:br/>
-            <a:r>
-              <a:rPr sz="2100" b="0" i="0">
-                <a:solidFill>
-                  <a:srgbClr val="20344A"/>
-                </a:solidFill>
-                <a:latin typeface="Arial"/>
-              </a:rPr>
-              <a:t>seven days.</a:t>
-            </a:r>
-          </a:p>
-        </p:txBody>
-      </p:sp>
-      <p:sp>
-        <p:nvSpPr>
-          <p:cNvPr id="9" name="content:line-277:0"/>
-          <p:cNvSpPr txBox="1"/>
-          <p:nvPr/>
-        </p:nvSpPr>
-        <p:spPr>
-          <a:xfrm>
-            <a:off x="594360" y="4974336"/>
-            <a:ext cx="11003279" cy="1132332"/>
+              <a:t>and explain exact fields, nulls, and tolerance.</a:t>
+            </a:r>
+          </a:p>
+        </p:txBody>
+      </p:sp>
+      <p:sp>
+        <p:nvSpPr>
+          <p:cNvPr id="11" name="content:line-279:0"/>
+          <p:cNvSpPr txBox="1"/>
+          <p:nvPr/>
+        </p:nvSpPr>
+        <p:spPr>
+          <a:xfrm>
+            <a:off x="594360" y="5606796"/>
+            <a:ext cx="11003279" cy="428244"/>
           </a:xfrm>
           <a:prstGeom prst="rect">
             <a:avLst/>
@@ -14012,27 +14075,7 @@
                 </a:solidFill>
                 <a:latin typeface="Arial"/>
               </a:rPr>
-              <a:t>Docker is absent on the slide-authoring host: local captures </a:t>
-            </a:r>
-            <a:br/>
-            <a:r>
-              <a:rPr sz="2100" b="0" i="0">
-                <a:solidFill>
-                  <a:srgbClr val="20344A"/>
-                </a:solidFill>
-                <a:latin typeface="Arial"/>
-              </a:rPr>
-              <a:t>can be checked there; container execution and browser </a:t>
-            </a:r>
-            <a:br/>
-            <a:r>
-              <a:rPr sz="2100" b="0" i="0">
-                <a:solidFill>
-                  <a:srgbClr val="20344A"/>
-                </a:solidFill>
-                <a:latin typeface="Arial"/>
-              </a:rPr>
-              <a:t>behavior cannot be claimed from those checks.</a:t>
+              <a:t>15 minutes: review a teammate's commands and evidence; </a:t>
             </a:r>
           </a:p>
         </p:txBody>
@@ -14146,7 +14189,7 @@
               </a:defRPr>
             </a:pPr>
             <a:r>
-              <a:t>SOURCE 3 / 23</a:t>
+              <a:t>SOURCE 3 / 22</a:t>
             </a:r>
           </a:p>
         </p:txBody>
@@ -14665,7 +14708,7 @@
               </a:defRPr>
             </a:pPr>
             <a:r>
-              <a:t>SOURCE 20 / 23  ·  CONTINUED 2</a:t>
+              <a:t>SOURCE 20 / 22  ·  CONTINUED 2</a:t>
             </a:r>
           </a:p>
         </p:txBody>
@@ -14716,7 +14759,7 @@
                 </a:solidFill>
                 <a:latin typeface="Arial"/>
               </a:rPr>
-              <a:t>What has actually been verified?</a:t>
+              <a:t>Break, then 90 minutes of guided practice</a:t>
             </a:r>
           </a:p>
         </p:txBody>
@@ -14768,13 +14811,65 @@
       </p:sp>
       <p:sp>
         <p:nvSpPr>
-          <p:cNvPr id="6" name="content:line-278:0"/>
+          <p:cNvPr id="6" name="content:line-279:1"/>
           <p:cNvSpPr txBox="1"/>
           <p:nvPr/>
         </p:nvSpPr>
         <p:spPr>
           <a:xfrm>
             <a:off x="594360" y="1737360"/>
+            <a:ext cx="11003279" cy="428244"/>
+          </a:xfrm>
+          <a:prstGeom prst="rect">
+            <a:avLst/>
+          </a:prstGeom>
+          <a:noFill/>
+        </p:spPr>
+        <p:txBody>
+          <a:bodyPr wrap="none" anchor="t" lIns="88900" rIns="88900" tIns="38100" bIns="38100">
+            <a:noAutofit/>
+          </a:bodyPr>
+          <a:lstStyle/>
+          <a:p>
+            <a:pPr marL="279400" indent="-215900">
+              <a:lnSpc>
+                <a:spcPts val="2772"/>
+              </a:lnSpc>
+              <a:spcBef>
+                <a:spcPts val="0"/>
+              </a:spcBef>
+              <a:spcAft>
+                <a:spcPts val="0"/>
+              </a:spcAft>
+              <a:defRPr sz="2100">
+                <a:solidFill>
+                  <a:srgbClr val="20344A"/>
+                </a:solidFill>
+                <a:latin typeface="Arial"/>
+              </a:defRPr>
+              <a:buChar char=" "/>
+            </a:pPr>
+            <a:r>
+              <a:rPr sz="2100" b="0" i="0">
+                <a:solidFill>
+                  <a:srgbClr val="20344A"/>
+                </a:solidFill>
+                <a:latin typeface="Arial"/>
+              </a:rPr>
+              <a:t>explain code/data hashes and any environment differences.</a:t>
+            </a:r>
+          </a:p>
+        </p:txBody>
+      </p:sp>
+      <p:sp>
+        <p:nvSpPr>
+          <p:cNvPr id="7" name="content:line-280:0"/>
+          <p:cNvSpPr txBox="1"/>
+          <p:nvPr/>
+        </p:nvSpPr>
+        <p:spPr>
+          <a:xfrm>
+            <a:off x="594360" y="2229612"/>
             <a:ext cx="11003279" cy="780288"/>
           </a:xfrm>
           <a:prstGeom prst="rect">
@@ -14813,7 +14908,7 @@
                 </a:solidFill>
                 <a:latin typeface="Arial"/>
               </a:rPr>
-              <a:t>PowerPoint rendering is also unverified here. Markdown is </a:t>
+              <a:t>Use the supplied framework and your group's declared </a:t>
             </a:r>
             <a:br/>
             <a:r>
@@ -14823,26 +14918,7 @@
                 </a:solidFill>
                 <a:latin typeface="Arial"/>
               </a:rPr>
-              <a:t>maintained for the </a:t>
-            </a:r>
-            <a:r>
-              <a:rPr sz="2100" b="0" i="0">
-                <a:solidFill>
-                  <a:srgbClr val="007F82"/>
-                </a:solidFill>
-                <a:latin typeface="Arial"/>
-                <a:hlinkClick r:id="rId2"/>
-              </a:rPr>
-              <a:t>editable converter</a:t>
-            </a:r>
-            <a:r>
-              <a:rPr sz="2100" b="0" i="0">
-                <a:solidFill>
-                  <a:srgbClr val="20344A"/>
-                </a:solidFill>
-                <a:latin typeface="Arial"/>
-              </a:rPr>
-              <a:t>.</a:t>
+              <a:t>behavior; UI polish and model complexity are not priorities.</a:t>
             </a:r>
           </a:p>
         </p:txBody>
@@ -14956,14 +15032,14 @@
               </a:defRPr>
             </a:pPr>
             <a:r>
-              <a:t>SOURCE 21 / 23</a:t>
-            </a:r>
-          </a:p>
-        </p:txBody>
-      </p:sp>
-      <p:sp>
-        <p:nvSpPr>
-          <p:cNvPr id="4" name="title:line-282"/>
+              <a:t>SOURCE 21 / 22</a:t>
+            </a:r>
+          </a:p>
+        </p:txBody>
+      </p:sp>
+      <p:sp>
+        <p:nvSpPr>
+          <p:cNvPr id="4" name="title:line-284"/>
           <p:cNvSpPr txBox="1"/>
           <p:nvPr/>
         </p:nvSpPr>
@@ -15007,7 +15083,7 @@
                 </a:solidFill>
                 <a:latin typeface="Arial"/>
               </a:rPr>
-              <a:t>Break, then 90 minutes of guided practice</a:t>
+              <a:t>Checkpoint and presentation preparation</a:t>
             </a:r>
           </a:p>
         </p:txBody>
@@ -15059,13 +15135,299 @@
       </p:sp>
       <p:sp>
         <p:nvSpPr>
-          <p:cNvPr id="6" name="content:line-284:0"/>
+          <p:cNvPr id="6" name="content:line-286:0"/>
           <p:cNvSpPr txBox="1"/>
           <p:nvPr/>
         </p:nvSpPr>
         <p:spPr>
           <a:xfrm>
             <a:off x="594360" y="1737360"/>
+            <a:ext cx="11003279" cy="780288"/>
+          </a:xfrm>
+          <a:prstGeom prst="rect">
+            <a:avLst/>
+          </a:prstGeom>
+          <a:noFill/>
+        </p:spPr>
+        <p:txBody>
+          <a:bodyPr wrap="none" anchor="t" lIns="88900" rIns="88900" tIns="38100" bIns="38100">
+            <a:noAutofit/>
+          </a:bodyPr>
+          <a:lstStyle/>
+          <a:p>
+            <a:pPr marL="279400" indent="-215900">
+              <a:lnSpc>
+                <a:spcPts val="2772"/>
+              </a:lnSpc>
+              <a:spcBef>
+                <a:spcPts val="0"/>
+              </a:spcBef>
+              <a:spcAft>
+                <a:spcPts val="0"/>
+              </a:spcAft>
+              <a:defRPr sz="2100">
+                <a:solidFill>
+                  <a:srgbClr val="20344A"/>
+                </a:solidFill>
+                <a:latin typeface="Arial"/>
+              </a:defRPr>
+              <a:buChar char="•"/>
+            </a:pPr>
+            <a:r>
+              <a:rPr sz="2100" b="0" i="0">
+                <a:solidFill>
+                  <a:srgbClr val="20344A"/>
+                </a:solidFill>
+                <a:latin typeface="Arial"/>
+              </a:rPr>
+              <a:t>Explain images versus containers, internal versus published </a:t>
+            </a:r>
+            <a:br/>
+            <a:r>
+              <a:rPr sz="2100" b="0" i="0">
+                <a:solidFill>
+                  <a:srgbClr val="20344A"/>
+                </a:solidFill>
+                <a:latin typeface="Arial"/>
+              </a:rPr>
+              <a:t>ports, and startup readiness.</a:t>
+            </a:r>
+          </a:p>
+        </p:txBody>
+      </p:sp>
+      <p:sp>
+        <p:nvSpPr>
+          <p:cNvPr id="7" name="content:line-287:0"/>
+          <p:cNvSpPr txBox="1"/>
+          <p:nvPr/>
+        </p:nvSpPr>
+        <p:spPr>
+          <a:xfrm>
+            <a:off x="594360" y="2581656"/>
+            <a:ext cx="11003279" cy="1132332"/>
+          </a:xfrm>
+          <a:prstGeom prst="rect">
+            <a:avLst/>
+          </a:prstGeom>
+          <a:noFill/>
+        </p:spPr>
+        <p:txBody>
+          <a:bodyPr wrap="none" anchor="t" lIns="88900" rIns="88900" tIns="38100" bIns="38100">
+            <a:noAutofit/>
+          </a:bodyPr>
+          <a:lstStyle/>
+          <a:p>
+            <a:pPr marL="279400" indent="-215900">
+              <a:lnSpc>
+                <a:spcPts val="2772"/>
+              </a:lnSpc>
+              <a:spcBef>
+                <a:spcPts val="0"/>
+              </a:spcBef>
+              <a:spcAft>
+                <a:spcPts val="0"/>
+              </a:spcAft>
+              <a:defRPr sz="2100">
+                <a:solidFill>
+                  <a:srgbClr val="20344A"/>
+                </a:solidFill>
+                <a:latin typeface="Arial"/>
+              </a:defRPr>
+              <a:buChar char="•"/>
+            </a:pPr>
+            <a:r>
+              <a:rPr sz="2100" b="0" i="0">
+                <a:solidFill>
+                  <a:srgbClr val="20344A"/>
+                </a:solidFill>
+                <a:latin typeface="Arial"/>
+              </a:rPr>
+              <a:t>Show working uploads, restored configuration, and matching </a:t>
+            </a:r>
+            <a:br/>
+            <a:r>
+              <a:rPr sz="2100" b="0" i="0">
+                <a:solidFill>
+                  <a:srgbClr val="20344A"/>
+                </a:solidFill>
+                <a:latin typeface="Arial"/>
+              </a:rPr>
+              <a:t>comparison outputs; retain commands, conditions, captures, </a:t>
+            </a:r>
+            <a:br/>
+            <a:r>
+              <a:rPr sz="2100" b="0" i="0">
+                <a:solidFill>
+                  <a:srgbClr val="20344A"/>
+                </a:solidFill>
+                <a:latin typeface="Arial"/>
+              </a:rPr>
+              <a:t>and logs.</a:t>
+            </a:r>
+          </a:p>
+        </p:txBody>
+      </p:sp>
+      <p:sp>
+        <p:nvSpPr>
+          <p:cNvPr id="8" name="content:line-288:0"/>
+          <p:cNvSpPr txBox="1"/>
+          <p:nvPr/>
+        </p:nvSpPr>
+        <p:spPr>
+          <a:xfrm>
+            <a:off x="594360" y="3777996"/>
+            <a:ext cx="11003279" cy="780288"/>
+          </a:xfrm>
+          <a:prstGeom prst="rect">
+            <a:avLst/>
+          </a:prstGeom>
+          <a:noFill/>
+        </p:spPr>
+        <p:txBody>
+          <a:bodyPr wrap="none" anchor="t" lIns="88900" rIns="88900" tIns="38100" bIns="38100">
+            <a:noAutofit/>
+          </a:bodyPr>
+          <a:lstStyle/>
+          <a:p>
+            <a:pPr marL="279400" indent="-215900">
+              <a:lnSpc>
+                <a:spcPts val="2772"/>
+              </a:lnSpc>
+              <a:spcBef>
+                <a:spcPts val="0"/>
+              </a:spcBef>
+              <a:spcAft>
+                <a:spcPts val="0"/>
+              </a:spcAft>
+              <a:defRPr sz="2100">
+                <a:solidFill>
+                  <a:srgbClr val="20344A"/>
+                </a:solidFill>
+                <a:latin typeface="Arial"/>
+              </a:defRPr>
+              <a:buChar char="•"/>
+            </a:pPr>
+            <a:r>
+              <a:rPr sz="2100" b="0" i="0">
+                <a:solidFill>
+                  <a:srgbClr val="20344A"/>
+                </a:solidFill>
+                <a:latin typeface="Arial"/>
+              </a:rPr>
+              <a:t>Finish the demonstration with </a:t>
+            </a:r>
+            <a:r>
+              <a:rPr sz="2100" b="0" i="0">
+                <a:solidFill>
+                  <a:srgbClr val="20344A"/>
+                </a:solidFill>
+                <a:latin typeface="Courier New"/>
+              </a:rPr>
+              <a:t>docker compose down</a:t>
+            </a:r>
+            <a:r>
+              <a:rPr sz="2100" b="0" i="0">
+                <a:solidFill>
+                  <a:srgbClr val="20344A"/>
+                </a:solidFill>
+                <a:latin typeface="Arial"/>
+              </a:rPr>
+              <a:t>; host </a:t>
+            </a:r>
+            <a:br/>
+            <a:r>
+              <a:rPr sz="2100" b="0" i="0">
+                <a:solidFill>
+                  <a:srgbClr val="20344A"/>
+                </a:solidFill>
+                <a:latin typeface="Arial"/>
+              </a:rPr>
+              <a:t>CSVs and built images remain.</a:t>
+            </a:r>
+          </a:p>
+        </p:txBody>
+      </p:sp>
+      <p:sp>
+        <p:nvSpPr>
+          <p:cNvPr id="9" name="content:line-289:0"/>
+          <p:cNvSpPr txBox="1"/>
+          <p:nvPr/>
+        </p:nvSpPr>
+        <p:spPr>
+          <a:xfrm>
+            <a:off x="594360" y="4622292"/>
+            <a:ext cx="11003279" cy="1132332"/>
+          </a:xfrm>
+          <a:prstGeom prst="rect">
+            <a:avLst/>
+          </a:prstGeom>
+          <a:noFill/>
+        </p:spPr>
+        <p:txBody>
+          <a:bodyPr wrap="none" anchor="t" lIns="88900" rIns="88900" tIns="38100" bIns="38100">
+            <a:noAutofit/>
+          </a:bodyPr>
+          <a:lstStyle/>
+          <a:p>
+            <a:pPr marL="279400" indent="-215900">
+              <a:lnSpc>
+                <a:spcPts val="2772"/>
+              </a:lnSpc>
+              <a:spcBef>
+                <a:spcPts val="0"/>
+              </a:spcBef>
+              <a:spcAft>
+                <a:spcPts val="0"/>
+              </a:spcAft>
+              <a:defRPr sz="2100">
+                <a:solidFill>
+                  <a:srgbClr val="20344A"/>
+                </a:solidFill>
+                <a:latin typeface="Arial"/>
+              </a:defRPr>
+              <a:buChar char="•"/>
+            </a:pPr>
+            <a:r>
+              <a:rPr sz="2100" b="0" i="0">
+                <a:solidFill>
+                  <a:srgbClr val="20344A"/>
+                </a:solidFill>
+                <a:latin typeface="Arial"/>
+              </a:rPr>
+              <a:t>Mandatory homework: about two hours rehearsing application </a:t>
+            </a:r>
+            <a:br/>
+            <a:r>
+              <a:rPr sz="2100" b="0" i="0">
+                <a:solidFill>
+                  <a:srgbClr val="20344A"/>
+                </a:solidFill>
+                <a:latin typeface="Arial"/>
+              </a:rPr>
+              <a:t>startup, validation, tests, comparisons, and navigation to </a:t>
+            </a:r>
+            <a:br/>
+            <a:r>
+              <a:rPr sz="2100" b="0" i="0">
+                <a:solidFill>
+                  <a:srgbClr val="20344A"/>
+                </a:solidFill>
+                <a:latin typeface="Arial"/>
+              </a:rPr>
+              <a:t>PR/review evidence.</a:t>
+            </a:r>
+          </a:p>
+        </p:txBody>
+      </p:sp>
+      <p:sp>
+        <p:nvSpPr>
+          <p:cNvPr id="10" name="content:line-290:0"/>
+          <p:cNvSpPr txBox="1"/>
+          <p:nvPr/>
+        </p:nvSpPr>
+        <p:spPr>
+          <a:xfrm>
+            <a:off x="594360" y="5818632"/>
             <a:ext cx="11003279" cy="428244"/>
           </a:xfrm>
           <a:prstGeom prst="rect">
@@ -15104,325 +15466,7 @@
                 </a:solidFill>
                 <a:latin typeface="Arial"/>
               </a:rPr>
-              <a:t>Take a 15-minute break before practice.</a:t>
-            </a:r>
-          </a:p>
-        </p:txBody>
-      </p:sp>
-      <p:sp>
-        <p:nvSpPr>
-          <p:cNvPr id="7" name="content:line-285:0"/>
-          <p:cNvSpPr txBox="1"/>
-          <p:nvPr/>
-        </p:nvSpPr>
-        <p:spPr>
-          <a:xfrm>
-            <a:off x="594360" y="2229612"/>
-            <a:ext cx="11003279" cy="780288"/>
-          </a:xfrm>
-          <a:prstGeom prst="rect">
-            <a:avLst/>
-          </a:prstGeom>
-          <a:noFill/>
-        </p:spPr>
-        <p:txBody>
-          <a:bodyPr wrap="none" anchor="t" lIns="88900" rIns="88900" tIns="38100" bIns="38100">
-            <a:noAutofit/>
-          </a:bodyPr>
-          <a:lstStyle/>
-          <a:p>
-            <a:pPr marL="279400" indent="-215900">
-              <a:lnSpc>
-                <a:spcPts val="2772"/>
-              </a:lnSpc>
-              <a:spcBef>
-                <a:spcPts val="0"/>
-              </a:spcBef>
-              <a:spcAft>
-                <a:spcPts val="0"/>
-              </a:spcAft>
-              <a:defRPr sz="2100">
-                <a:solidFill>
-                  <a:srgbClr val="20344A"/>
-                </a:solidFill>
-                <a:latin typeface="Arial"/>
-              </a:defRPr>
-              <a:buChar char="•"/>
-            </a:pPr>
-            <a:r>
-              <a:rPr sz="2100" b="0" i="0">
-                <a:solidFill>
-                  <a:srgbClr val="20344A"/>
-                </a:solidFill>
-                <a:latin typeface="Arial"/>
-              </a:rPr>
-              <a:t>15 minutes: trace uploads, HTTP, </a:t>
-            </a:r>
-            <a:r>
-              <a:rPr sz="2100" b="0" i="0">
-                <a:solidFill>
-                  <a:srgbClr val="20344A"/>
-                </a:solidFill>
-                <a:latin typeface="Courier New"/>
-              </a:rPr>
-              <a:t>stat_core</a:t>
-            </a:r>
-            <a:r>
-              <a:rPr sz="2100" b="0" i="0">
-                <a:solidFill>
-                  <a:srgbClr val="20344A"/>
-                </a:solidFill>
-                <a:latin typeface="Arial"/>
-              </a:rPr>
-              <a:t>, and each caller's </a:t>
-            </a:r>
-            <a:br/>
-            <a:r>
-              <a:rPr sz="2100" b="0" i="0">
-                <a:solidFill>
-                  <a:srgbClr val="20344A"/>
-                </a:solidFill>
-                <a:latin typeface="Arial"/>
-              </a:rPr>
-              <a:t>address.</a:t>
-            </a:r>
-          </a:p>
-        </p:txBody>
-      </p:sp>
-      <p:sp>
-        <p:nvSpPr>
-          <p:cNvPr id="8" name="content:line-286:0"/>
-          <p:cNvSpPr txBox="1"/>
-          <p:nvPr/>
-        </p:nvSpPr>
-        <p:spPr>
-          <a:xfrm>
-            <a:off x="594360" y="3073908"/>
-            <a:ext cx="11003279" cy="780288"/>
-          </a:xfrm>
-          <a:prstGeom prst="rect">
-            <a:avLst/>
-          </a:prstGeom>
-          <a:noFill/>
-        </p:spPr>
-        <p:txBody>
-          <a:bodyPr wrap="none" anchor="t" lIns="88900" rIns="88900" tIns="38100" bIns="38100">
-            <a:noAutofit/>
-          </a:bodyPr>
-          <a:lstStyle/>
-          <a:p>
-            <a:pPr marL="279400" indent="-215900">
-              <a:lnSpc>
-                <a:spcPts val="2772"/>
-              </a:lnSpc>
-              <a:spcBef>
-                <a:spcPts val="0"/>
-              </a:spcBef>
-              <a:spcAft>
-                <a:spcPts val="0"/>
-              </a:spcAft>
-              <a:defRPr sz="2100">
-                <a:solidFill>
-                  <a:srgbClr val="20344A"/>
-                </a:solidFill>
-                <a:latin typeface="Arial"/>
-              </a:defRPr>
-              <a:buChar char="•"/>
-            </a:pPr>
-            <a:r>
-              <a:rPr sz="2100" b="0" i="0">
-                <a:solidFill>
-                  <a:srgbClr val="20344A"/>
-                </a:solidFill>
-                <a:latin typeface="Arial"/>
-              </a:rPr>
-              <a:t>20 minutes: launch the supplied stack, upload both CSVs, </a:t>
-            </a:r>
-            <a:br/>
-            <a:r>
-              <a:rPr sz="2100" b="0" i="0">
-                <a:solidFill>
-                  <a:srgbClr val="20344A"/>
-                </a:solidFill>
-                <a:latin typeface="Arial"/>
-              </a:rPr>
-              <a:t>inspect health and logs.</a:t>
-            </a:r>
-          </a:p>
-        </p:txBody>
-      </p:sp>
-      <p:sp>
-        <p:nvSpPr>
-          <p:cNvPr id="9" name="content:line-287:0"/>
-          <p:cNvSpPr txBox="1"/>
-          <p:nvPr/>
-        </p:nvSpPr>
-        <p:spPr>
-          <a:xfrm>
-            <a:off x="594360" y="3918204"/>
-            <a:ext cx="11003279" cy="780288"/>
-          </a:xfrm>
-          <a:prstGeom prst="rect">
-            <a:avLst/>
-          </a:prstGeom>
-          <a:noFill/>
-        </p:spPr>
-        <p:txBody>
-          <a:bodyPr wrap="none" anchor="t" lIns="88900" rIns="88900" tIns="38100" bIns="38100">
-            <a:noAutofit/>
-          </a:bodyPr>
-          <a:lstStyle/>
-          <a:p>
-            <a:pPr marL="279400" indent="-215900">
-              <a:lnSpc>
-                <a:spcPts val="2772"/>
-              </a:lnSpc>
-              <a:spcBef>
-                <a:spcPts val="0"/>
-              </a:spcBef>
-              <a:spcAft>
-                <a:spcPts val="0"/>
-              </a:spcAft>
-              <a:defRPr sz="2100">
-                <a:solidFill>
-                  <a:srgbClr val="20344A"/>
-                </a:solidFill>
-                <a:latin typeface="Arial"/>
-              </a:defRPr>
-              <a:buChar char="•"/>
-            </a:pPr>
-            <a:r>
-              <a:rPr sz="2100" b="0" i="0">
-                <a:solidFill>
-                  <a:srgbClr val="20344A"/>
-                </a:solidFill>
-                <a:latin typeface="Arial"/>
-              </a:rPr>
-              <a:t>15 minutes: repeat the temporary local address failure and </a:t>
-            </a:r>
-            <a:br/>
-            <a:r>
-              <a:rPr sz="2100" b="0" i="0">
-                <a:solidFill>
-                  <a:srgbClr val="20344A"/>
-                </a:solidFill>
-                <a:latin typeface="Arial"/>
-              </a:rPr>
-              <a:t>recovery; restore a working stack.</a:t>
-            </a:r>
-          </a:p>
-        </p:txBody>
-      </p:sp>
-      <p:sp>
-        <p:nvSpPr>
-          <p:cNvPr id="10" name="content:line-288:0"/>
-          <p:cNvSpPr txBox="1"/>
-          <p:nvPr/>
-        </p:nvSpPr>
-        <p:spPr>
-          <a:xfrm>
-            <a:off x="594360" y="4762500"/>
-            <a:ext cx="11003279" cy="780288"/>
-          </a:xfrm>
-          <a:prstGeom prst="rect">
-            <a:avLst/>
-          </a:prstGeom>
-          <a:noFill/>
-        </p:spPr>
-        <p:txBody>
-          <a:bodyPr wrap="none" anchor="t" lIns="88900" rIns="88900" tIns="38100" bIns="38100">
-            <a:noAutofit/>
-          </a:bodyPr>
-          <a:lstStyle/>
-          <a:p>
-            <a:pPr marL="279400" indent="-215900">
-              <a:lnSpc>
-                <a:spcPts val="2772"/>
-              </a:lnSpc>
-              <a:spcBef>
-                <a:spcPts val="0"/>
-              </a:spcBef>
-              <a:spcAft>
-                <a:spcPts val="0"/>
-              </a:spcAft>
-              <a:defRPr sz="2100">
-                <a:solidFill>
-                  <a:srgbClr val="20344A"/>
-                </a:solidFill>
-                <a:latin typeface="Arial"/>
-              </a:defRPr>
-              <a:buChar char="•"/>
-            </a:pPr>
-            <a:r>
-              <a:rPr sz="2100" b="0" i="0">
-                <a:solidFill>
-                  <a:srgbClr val="20344A"/>
-                </a:solidFill>
-                <a:latin typeface="Arial"/>
-              </a:rPr>
-              <a:t>25 minutes: capture twice locally and once in Docker; compare </a:t>
-            </a:r>
-            <a:br/>
-            <a:r>
-              <a:rPr sz="2100" b="0" i="0">
-                <a:solidFill>
-                  <a:srgbClr val="20344A"/>
-                </a:solidFill>
-                <a:latin typeface="Arial"/>
-              </a:rPr>
-              <a:t>and explain exact fields, nulls, and tolerance.</a:t>
-            </a:r>
-          </a:p>
-        </p:txBody>
-      </p:sp>
-      <p:sp>
-        <p:nvSpPr>
-          <p:cNvPr id="11" name="content:line-289:0"/>
-          <p:cNvSpPr txBox="1"/>
-          <p:nvPr/>
-        </p:nvSpPr>
-        <p:spPr>
-          <a:xfrm>
-            <a:off x="594360" y="5606796"/>
-            <a:ext cx="11003279" cy="428244"/>
-          </a:xfrm>
-          <a:prstGeom prst="rect">
-            <a:avLst/>
-          </a:prstGeom>
-          <a:noFill/>
-        </p:spPr>
-        <p:txBody>
-          <a:bodyPr wrap="none" anchor="t" lIns="88900" rIns="88900" tIns="38100" bIns="38100">
-            <a:noAutofit/>
-          </a:bodyPr>
-          <a:lstStyle/>
-          <a:p>
-            <a:pPr marL="279400" indent="-215900">
-              <a:lnSpc>
-                <a:spcPts val="2772"/>
-              </a:lnSpc>
-              <a:spcBef>
-                <a:spcPts val="0"/>
-              </a:spcBef>
-              <a:spcAft>
-                <a:spcPts val="0"/>
-              </a:spcAft>
-              <a:defRPr sz="2100">
-                <a:solidFill>
-                  <a:srgbClr val="20344A"/>
-                </a:solidFill>
-                <a:latin typeface="Arial"/>
-              </a:defRPr>
-              <a:buChar char="•"/>
-            </a:pPr>
-            <a:r>
-              <a:rPr sz="2100" b="0" i="0">
-                <a:solidFill>
-                  <a:srgbClr val="20344A"/>
-                </a:solidFill>
-                <a:latin typeface="Arial"/>
-              </a:rPr>
-              <a:t>15 minutes: review a teammate's commands and evidence; </a:t>
+              <a:t>Every student needs an authored PR and meaningful peer </a:t>
             </a:r>
           </a:p>
         </p:txBody>
@@ -15536,14 +15580,14 @@
               </a:defRPr>
             </a:pPr>
             <a:r>
-              <a:t>SOURCE 21 / 23  ·  CONTINUED 2</a:t>
-            </a:r>
-          </a:p>
-        </p:txBody>
-      </p:sp>
-      <p:sp>
-        <p:nvSpPr>
-          <p:cNvPr id="4" name="title:line-282"/>
+              <a:t>SOURCE 21 / 22  ·  CONTINUED 2</a:t>
+            </a:r>
+          </a:p>
+        </p:txBody>
+      </p:sp>
+      <p:sp>
+        <p:nvSpPr>
+          <p:cNvPr id="4" name="title:line-284"/>
           <p:cNvSpPr txBox="1"/>
           <p:nvPr/>
         </p:nvSpPr>
@@ -15587,7 +15631,7 @@
                 </a:solidFill>
                 <a:latin typeface="Arial"/>
               </a:rPr>
-              <a:t>Break, then 90 minutes of guided practice</a:t>
+              <a:t>Checkpoint and presentation preparation</a:t>
             </a:r>
           </a:p>
         </p:txBody>
@@ -15639,14 +15683,14 @@
       </p:sp>
       <p:sp>
         <p:nvSpPr>
-          <p:cNvPr id="6" name="content:line-289:1"/>
+          <p:cNvPr id="6" name="content:line-290:1"/>
           <p:cNvSpPr txBox="1"/>
           <p:nvPr/>
         </p:nvSpPr>
         <p:spPr>
           <a:xfrm>
             <a:off x="594360" y="1737360"/>
-            <a:ext cx="11003279" cy="428244"/>
+            <a:ext cx="11003279" cy="780288"/>
           </a:xfrm>
           <a:prstGeom prst="rect">
             <a:avLst/>
@@ -15684,21 +15728,31 @@
                 </a:solidFill>
                 <a:latin typeface="Arial"/>
               </a:rPr>
-              <a:t>explain code/data hashes and any environment differences.</a:t>
-            </a:r>
-          </a:p>
-        </p:txBody>
-      </p:sp>
-      <p:sp>
-        <p:nvSpPr>
-          <p:cNvPr id="7" name="content:line-290:0"/>
-          <p:cNvSpPr txBox="1"/>
-          <p:nvPr/>
-        </p:nvSpPr>
-        <p:spPr>
-          <a:xfrm>
-            <a:off x="594360" y="2229612"/>
-            <a:ext cx="11003279" cy="780288"/>
+              <a:t>review. Prepare for the final presentation's pass/fail </a:t>
+            </a:r>
+            <a:br/>
+            <a:r>
+              <a:rPr sz="2100" b="0" i="0">
+                <a:solidFill>
+                  <a:srgbClr val="20344A"/>
+                </a:solidFill>
+                <a:latin typeface="Arial"/>
+              </a:rPr>
+              <a:t>engineering checks.</a:t>
+            </a:r>
+          </a:p>
+        </p:txBody>
+      </p:sp>
+      <p:sp>
+        <p:nvSpPr>
+          <p:cNvPr id="7" name="content:line-291:0"/>
+          <p:cNvSpPr txBox="1"/>
+          <p:nvPr/>
+        </p:nvSpPr>
+        <p:spPr>
+          <a:xfrm>
+            <a:off x="594360" y="2581656"/>
+            <a:ext cx="11003279" cy="1132332"/>
           </a:xfrm>
           <a:prstGeom prst="rect">
             <a:avLst/>
@@ -15736,7 +15790,7 @@
                 </a:solidFill>
                 <a:latin typeface="Arial"/>
               </a:rPr>
-              <a:t>Use the supplied framework and your group's declared </a:t>
+              <a:t>This checkpoint is preparation, not a separate assessed </a:t>
             </a:r>
             <a:br/>
             <a:r>
@@ -15746,7 +15800,36 @@
                 </a:solidFill>
                 <a:latin typeface="Arial"/>
               </a:rPr>
-              <a:t>behavior; UI polish and model complexity are not priorities.</a:t>
+              <a:t>submission. Final presentation has no resubmission or </a:t>
+            </a:r>
+            <a:br/>
+            <a:r>
+              <a:rPr sz="2100" b="0" i="0">
+                <a:solidFill>
+                  <a:srgbClr val="20344A"/>
+                </a:solidFill>
+                <a:latin typeface="Arial"/>
+              </a:rPr>
+              <a:t>reassessment; see </a:t>
+            </a:r>
+            <a:r>
+              <a:rPr sz="2100" b="0" i="0">
+                <a:solidFill>
+                  <a:srgbClr val="007F82"/>
+                </a:solidFill>
+                <a:latin typeface="Arial"/>
+                <a:hlinkClick r:id="rId2"/>
+              </a:rPr>
+              <a:t>assessment policy</a:t>
+            </a:r>
+            <a:r>
+              <a:rPr sz="2100" b="0" i="0">
+                <a:solidFill>
+                  <a:srgbClr val="20344A"/>
+                </a:solidFill>
+                <a:latin typeface="Arial"/>
+              </a:rPr>
+              <a:t>.</a:t>
             </a:r>
           </a:p>
         </p:txBody>
@@ -15860,14 +15943,14 @@
               </a:defRPr>
             </a:pPr>
             <a:r>
-              <a:t>SOURCE 22 / 23</a:t>
-            </a:r>
-          </a:p>
-        </p:txBody>
-      </p:sp>
-      <p:sp>
-        <p:nvSpPr>
-          <p:cNvPr id="4" name="title:line-294"/>
+              <a:t>SOURCE 22 / 22</a:t>
+            </a:r>
+          </a:p>
+        </p:txBody>
+      </p:sp>
+      <p:sp>
+        <p:nvSpPr>
+          <p:cNvPr id="4" name="title:line-295"/>
           <p:cNvSpPr txBox="1"/>
           <p:nvPr/>
         </p:nvSpPr>
@@ -15911,7 +15994,7 @@
                 </a:solidFill>
                 <a:latin typeface="Arial"/>
               </a:rPr>
-              <a:t>Checkpoint and presentation preparation</a:t>
+              <a:t>Source map for rehearsal</a:t>
             </a:r>
           </a:p>
         </p:txBody>
@@ -15963,918 +16046,7 @@
       </p:sp>
       <p:sp>
         <p:nvSpPr>
-          <p:cNvPr id="6" name="content:line-296:0"/>
-          <p:cNvSpPr txBox="1"/>
-          <p:nvPr/>
-        </p:nvSpPr>
-        <p:spPr>
-          <a:xfrm>
-            <a:off x="594360" y="1737360"/>
-            <a:ext cx="11003279" cy="780288"/>
-          </a:xfrm>
-          <a:prstGeom prst="rect">
-            <a:avLst/>
-          </a:prstGeom>
-          <a:noFill/>
-        </p:spPr>
-        <p:txBody>
-          <a:bodyPr wrap="none" anchor="t" lIns="88900" rIns="88900" tIns="38100" bIns="38100">
-            <a:noAutofit/>
-          </a:bodyPr>
-          <a:lstStyle/>
-          <a:p>
-            <a:pPr marL="279400" indent="-215900">
-              <a:lnSpc>
-                <a:spcPts val="2772"/>
-              </a:lnSpc>
-              <a:spcBef>
-                <a:spcPts val="0"/>
-              </a:spcBef>
-              <a:spcAft>
-                <a:spcPts val="0"/>
-              </a:spcAft>
-              <a:defRPr sz="2100">
-                <a:solidFill>
-                  <a:srgbClr val="20344A"/>
-                </a:solidFill>
-                <a:latin typeface="Arial"/>
-              </a:defRPr>
-              <a:buChar char="•"/>
-            </a:pPr>
-            <a:r>
-              <a:rPr sz="2100" b="0" i="0">
-                <a:solidFill>
-                  <a:srgbClr val="20344A"/>
-                </a:solidFill>
-                <a:latin typeface="Arial"/>
-              </a:rPr>
-              <a:t>Explain images versus containers, internal versus published </a:t>
-            </a:r>
-            <a:br/>
-            <a:r>
-              <a:rPr sz="2100" b="0" i="0">
-                <a:solidFill>
-                  <a:srgbClr val="20344A"/>
-                </a:solidFill>
-                <a:latin typeface="Arial"/>
-              </a:rPr>
-              <a:t>ports, and startup readiness.</a:t>
-            </a:r>
-          </a:p>
-        </p:txBody>
-      </p:sp>
-      <p:sp>
-        <p:nvSpPr>
-          <p:cNvPr id="7" name="content:line-297:0"/>
-          <p:cNvSpPr txBox="1"/>
-          <p:nvPr/>
-        </p:nvSpPr>
-        <p:spPr>
-          <a:xfrm>
-            <a:off x="594360" y="2581656"/>
-            <a:ext cx="11003279" cy="1132332"/>
-          </a:xfrm>
-          <a:prstGeom prst="rect">
-            <a:avLst/>
-          </a:prstGeom>
-          <a:noFill/>
-        </p:spPr>
-        <p:txBody>
-          <a:bodyPr wrap="none" anchor="t" lIns="88900" rIns="88900" tIns="38100" bIns="38100">
-            <a:noAutofit/>
-          </a:bodyPr>
-          <a:lstStyle/>
-          <a:p>
-            <a:pPr marL="279400" indent="-215900">
-              <a:lnSpc>
-                <a:spcPts val="2772"/>
-              </a:lnSpc>
-              <a:spcBef>
-                <a:spcPts val="0"/>
-              </a:spcBef>
-              <a:spcAft>
-                <a:spcPts val="0"/>
-              </a:spcAft>
-              <a:defRPr sz="2100">
-                <a:solidFill>
-                  <a:srgbClr val="20344A"/>
-                </a:solidFill>
-                <a:latin typeface="Arial"/>
-              </a:defRPr>
-              <a:buChar char="•"/>
-            </a:pPr>
-            <a:r>
-              <a:rPr sz="2100" b="0" i="0">
-                <a:solidFill>
-                  <a:srgbClr val="20344A"/>
-                </a:solidFill>
-                <a:latin typeface="Arial"/>
-              </a:rPr>
-              <a:t>Show working uploads, restored configuration, and matching </a:t>
-            </a:r>
-            <a:br/>
-            <a:r>
-              <a:rPr sz="2100" b="0" i="0">
-                <a:solidFill>
-                  <a:srgbClr val="20344A"/>
-                </a:solidFill>
-                <a:latin typeface="Arial"/>
-              </a:rPr>
-              <a:t>comparison outputs; retain commands, conditions, captures, </a:t>
-            </a:r>
-            <a:br/>
-            <a:r>
-              <a:rPr sz="2100" b="0" i="0">
-                <a:solidFill>
-                  <a:srgbClr val="20344A"/>
-                </a:solidFill>
-                <a:latin typeface="Arial"/>
-              </a:rPr>
-              <a:t>and logs.</a:t>
-            </a:r>
-          </a:p>
-        </p:txBody>
-      </p:sp>
-      <p:sp>
-        <p:nvSpPr>
-          <p:cNvPr id="8" name="content:line-298:0"/>
-          <p:cNvSpPr txBox="1"/>
-          <p:nvPr/>
-        </p:nvSpPr>
-        <p:spPr>
-          <a:xfrm>
-            <a:off x="594360" y="3777996"/>
-            <a:ext cx="11003279" cy="780288"/>
-          </a:xfrm>
-          <a:prstGeom prst="rect">
-            <a:avLst/>
-          </a:prstGeom>
-          <a:noFill/>
-        </p:spPr>
-        <p:txBody>
-          <a:bodyPr wrap="none" anchor="t" lIns="88900" rIns="88900" tIns="38100" bIns="38100">
-            <a:noAutofit/>
-          </a:bodyPr>
-          <a:lstStyle/>
-          <a:p>
-            <a:pPr marL="279400" indent="-215900">
-              <a:lnSpc>
-                <a:spcPts val="2772"/>
-              </a:lnSpc>
-              <a:spcBef>
-                <a:spcPts val="0"/>
-              </a:spcBef>
-              <a:spcAft>
-                <a:spcPts val="0"/>
-              </a:spcAft>
-              <a:defRPr sz="2100">
-                <a:solidFill>
-                  <a:srgbClr val="20344A"/>
-                </a:solidFill>
-                <a:latin typeface="Arial"/>
-              </a:defRPr>
-              <a:buChar char="•"/>
-            </a:pPr>
-            <a:r>
-              <a:rPr sz="2100" b="0" i="0">
-                <a:solidFill>
-                  <a:srgbClr val="20344A"/>
-                </a:solidFill>
-                <a:latin typeface="Arial"/>
-              </a:rPr>
-              <a:t>Finish the demonstration with </a:t>
-            </a:r>
-            <a:r>
-              <a:rPr sz="2100" b="0" i="0">
-                <a:solidFill>
-                  <a:srgbClr val="20344A"/>
-                </a:solidFill>
-                <a:latin typeface="Courier New"/>
-              </a:rPr>
-              <a:t>docker compose down</a:t>
-            </a:r>
-            <a:r>
-              <a:rPr sz="2100" b="0" i="0">
-                <a:solidFill>
-                  <a:srgbClr val="20344A"/>
-                </a:solidFill>
-                <a:latin typeface="Arial"/>
-              </a:rPr>
-              <a:t>; host </a:t>
-            </a:r>
-            <a:br/>
-            <a:r>
-              <a:rPr sz="2100" b="0" i="0">
-                <a:solidFill>
-                  <a:srgbClr val="20344A"/>
-                </a:solidFill>
-                <a:latin typeface="Arial"/>
-              </a:rPr>
-              <a:t>CSVs and built images remain.</a:t>
-            </a:r>
-          </a:p>
-        </p:txBody>
-      </p:sp>
-      <p:sp>
-        <p:nvSpPr>
-          <p:cNvPr id="9" name="content:line-299:0"/>
-          <p:cNvSpPr txBox="1"/>
-          <p:nvPr/>
-        </p:nvSpPr>
-        <p:spPr>
-          <a:xfrm>
-            <a:off x="594360" y="4622292"/>
-            <a:ext cx="11003279" cy="1132332"/>
-          </a:xfrm>
-          <a:prstGeom prst="rect">
-            <a:avLst/>
-          </a:prstGeom>
-          <a:noFill/>
-        </p:spPr>
-        <p:txBody>
-          <a:bodyPr wrap="none" anchor="t" lIns="88900" rIns="88900" tIns="38100" bIns="38100">
-            <a:noAutofit/>
-          </a:bodyPr>
-          <a:lstStyle/>
-          <a:p>
-            <a:pPr marL="279400" indent="-215900">
-              <a:lnSpc>
-                <a:spcPts val="2772"/>
-              </a:lnSpc>
-              <a:spcBef>
-                <a:spcPts val="0"/>
-              </a:spcBef>
-              <a:spcAft>
-                <a:spcPts val="0"/>
-              </a:spcAft>
-              <a:defRPr sz="2100">
-                <a:solidFill>
-                  <a:srgbClr val="20344A"/>
-                </a:solidFill>
-                <a:latin typeface="Arial"/>
-              </a:defRPr>
-              <a:buChar char="•"/>
-            </a:pPr>
-            <a:r>
-              <a:rPr sz="2100" b="0" i="0">
-                <a:solidFill>
-                  <a:srgbClr val="20344A"/>
-                </a:solidFill>
-                <a:latin typeface="Arial"/>
-              </a:rPr>
-              <a:t>Mandatory homework: about two hours rehearsing application </a:t>
-            </a:r>
-            <a:br/>
-            <a:r>
-              <a:rPr sz="2100" b="0" i="0">
-                <a:solidFill>
-                  <a:srgbClr val="20344A"/>
-                </a:solidFill>
-                <a:latin typeface="Arial"/>
-              </a:rPr>
-              <a:t>startup, validation, tests, comparisons, and navigation to </a:t>
-            </a:r>
-            <a:br/>
-            <a:r>
-              <a:rPr sz="2100" b="0" i="0">
-                <a:solidFill>
-                  <a:srgbClr val="20344A"/>
-                </a:solidFill>
-                <a:latin typeface="Arial"/>
-              </a:rPr>
-              <a:t>PR/review evidence.</a:t>
-            </a:r>
-          </a:p>
-        </p:txBody>
-      </p:sp>
-      <p:sp>
-        <p:nvSpPr>
-          <p:cNvPr id="10" name="content:line-300:0"/>
-          <p:cNvSpPr txBox="1"/>
-          <p:nvPr/>
-        </p:nvSpPr>
-        <p:spPr>
-          <a:xfrm>
-            <a:off x="594360" y="5818632"/>
-            <a:ext cx="11003279" cy="428244"/>
-          </a:xfrm>
-          <a:prstGeom prst="rect">
-            <a:avLst/>
-          </a:prstGeom>
-          <a:noFill/>
-        </p:spPr>
-        <p:txBody>
-          <a:bodyPr wrap="none" anchor="t" lIns="88900" rIns="88900" tIns="38100" bIns="38100">
-            <a:noAutofit/>
-          </a:bodyPr>
-          <a:lstStyle/>
-          <a:p>
-            <a:pPr marL="279400" indent="-215900">
-              <a:lnSpc>
-                <a:spcPts val="2772"/>
-              </a:lnSpc>
-              <a:spcBef>
-                <a:spcPts val="0"/>
-              </a:spcBef>
-              <a:spcAft>
-                <a:spcPts val="0"/>
-              </a:spcAft>
-              <a:defRPr sz="2100">
-                <a:solidFill>
-                  <a:srgbClr val="20344A"/>
-                </a:solidFill>
-                <a:latin typeface="Arial"/>
-              </a:defRPr>
-              <a:buChar char="•"/>
-            </a:pPr>
-            <a:r>
-              <a:rPr sz="2100" b="0" i="0">
-                <a:solidFill>
-                  <a:srgbClr val="20344A"/>
-                </a:solidFill>
-                <a:latin typeface="Arial"/>
-              </a:rPr>
-              <a:t>Every student needs an authored PR and meaningful peer </a:t>
-            </a:r>
-          </a:p>
-        </p:txBody>
-      </p:sp>
-    </p:spTree>
-  </p:cSld>
-  <p:clrMapOvr>
-    <a:masterClrMapping/>
-  </p:clrMapOvr>
-</p:sld>
-</file>
-
-<file path=ppt/slides/slide34.xml><?xml version="1.0" encoding="utf-8"?>
-<p:sld xmlns:a="http://schemas.openxmlformats.org/drawingml/2006/main" xmlns:p="http://schemas.openxmlformats.org/presentationml/2006/main" xmlns:r="http://schemas.openxmlformats.org/officeDocument/2006/relationships">
-  <p:cSld>
-    <p:bg>
-      <p:bgPr>
-        <a:solidFill>
-          <a:srgbClr val="FAFCFD"/>
-        </a:solidFill>
-        <a:effectLst/>
-      </p:bgPr>
-    </p:bg>
-    <p:spTree>
-      <p:nvGrpSpPr>
-        <p:cNvPr id="1" name=""/>
-        <p:cNvGrpSpPr/>
-        <p:nvPr/>
-      </p:nvGrpSpPr>
-      <p:grpSpPr/>
-      <p:sp>
-        <p:nvSpPr>
-          <p:cNvPr id="2" name="accent"/>
-          <p:cNvSpPr/>
-          <p:nvPr/>
-        </p:nvSpPr>
-        <p:spPr>
-          <a:xfrm>
-            <a:off x="0" y="0"/>
-            <a:ext cx="12191999" cy="64008"/>
-          </a:xfrm>
-          <a:prstGeom prst="rect">
-            <a:avLst/>
-          </a:prstGeom>
-          <a:solidFill>
-            <a:srgbClr val="007F82"/>
-          </a:solidFill>
-          <a:ln>
-            <a:noFill/>
-          </a:ln>
-        </p:spPr>
-        <p:style>
-          <a:lnRef idx="1">
-            <a:schemeClr val="accent1"/>
-          </a:lnRef>
-          <a:fillRef idx="3">
-            <a:schemeClr val="accent1"/>
-          </a:fillRef>
-          <a:effectRef idx="2">
-            <a:schemeClr val="accent1"/>
-          </a:effectRef>
-          <a:fontRef idx="minor">
-            <a:schemeClr val="lt1"/>
-          </a:fontRef>
-        </p:style>
-        <p:txBody>
-          <a:bodyPr rtlCol="0" anchor="ctr"/>
-          <a:lstStyle/>
-          <a:p>
-            <a:pPr algn="ctr"/>
-          </a:p>
-        </p:txBody>
-      </p:sp>
-      <p:sp>
-        <p:nvSpPr>
-          <p:cNvPr id="3" name="section"/>
-          <p:cNvSpPr txBox="1"/>
-          <p:nvPr/>
-        </p:nvSpPr>
-        <p:spPr>
-          <a:xfrm>
-            <a:off x="594360" y="201168"/>
-            <a:ext cx="11003279" cy="256032"/>
-          </a:xfrm>
-          <a:prstGeom prst="rect">
-            <a:avLst/>
-          </a:prstGeom>
-          <a:noFill/>
-        </p:spPr>
-        <p:txBody>
-          <a:bodyPr wrap="none" anchor="t" lIns="88900" rIns="88900" tIns="38100" bIns="38100">
-            <a:noAutofit/>
-          </a:bodyPr>
-          <a:lstStyle/>
-          <a:p>
-            <a:pPr>
-              <a:lnSpc>
-                <a:spcPts val="1452"/>
-              </a:lnSpc>
-              <a:spcBef>
-                <a:spcPts val="0"/>
-              </a:spcBef>
-              <a:spcAft>
-                <a:spcPts val="0"/>
-              </a:spcAft>
-              <a:defRPr sz="1100">
-                <a:solidFill>
-                  <a:srgbClr val="53677A"/>
-                </a:solidFill>
-                <a:latin typeface="Arial"/>
-              </a:defRPr>
-            </a:pPr>
-            <a:r>
-              <a:t>SOURCE 22 / 23  ·  CONTINUED 2</a:t>
-            </a:r>
-          </a:p>
-        </p:txBody>
-      </p:sp>
-      <p:sp>
-        <p:nvSpPr>
-          <p:cNvPr id="4" name="title:line-294"/>
-          <p:cNvSpPr txBox="1"/>
-          <p:nvPr/>
-        </p:nvSpPr>
-        <p:spPr>
-          <a:xfrm>
-            <a:off x="594360" y="530352"/>
-            <a:ext cx="11003279" cy="1161288"/>
-          </a:xfrm>
-          <a:prstGeom prst="rect">
-            <a:avLst/>
-          </a:prstGeom>
-          <a:noFill/>
-        </p:spPr>
-        <p:txBody>
-          <a:bodyPr wrap="none" anchor="t" lIns="88900" rIns="88900" tIns="38100" bIns="38100">
-            <a:noAutofit/>
-          </a:bodyPr>
-          <a:lstStyle/>
-          <a:p>
-            <a:pPr>
-              <a:lnSpc>
-                <a:spcPts val="4000"/>
-              </a:lnSpc>
-              <a:spcBef>
-                <a:spcPts val="0"/>
-              </a:spcBef>
-              <a:spcAft>
-                <a:spcPts val="0"/>
-              </a:spcAft>
-              <a:defRPr sz="3200">
-                <a:solidFill>
-                  <a:srgbClr val="20344A"/>
-                </a:solidFill>
-                <a:latin typeface="Arial"/>
-              </a:defRPr>
-            </a:pPr>
-            <a:r>
-              <a:rPr sz="3200" b="0" i="0">
-                <a:solidFill>
-                  <a:srgbClr val="20344A"/>
-                </a:solidFill>
-                <a:latin typeface="Arial"/>
-              </a:rPr>
-              <a:t>Checkpoint and presentation preparation</a:t>
-            </a:r>
-          </a:p>
-        </p:txBody>
-      </p:sp>
-      <p:sp>
-        <p:nvSpPr>
-          <p:cNvPr id="5" name="footer"/>
-          <p:cNvSpPr txBox="1"/>
-          <p:nvPr/>
-        </p:nvSpPr>
-        <p:spPr>
-          <a:xfrm>
-            <a:off x="594360" y="6510528"/>
-            <a:ext cx="11003279" cy="219456"/>
-          </a:xfrm>
-          <a:prstGeom prst="rect">
-            <a:avLst/>
-          </a:prstGeom>
-          <a:noFill/>
-        </p:spPr>
-        <p:txBody>
-          <a:bodyPr wrap="none" anchor="t" lIns="88900" rIns="88900" tIns="38100" bIns="38100">
-            <a:noAutofit/>
-          </a:bodyPr>
-          <a:lstStyle/>
-          <a:p>
-            <a:pPr>
-              <a:lnSpc>
-                <a:spcPts val="1320"/>
-              </a:lnSpc>
-              <a:spcBef>
-                <a:spcPts val="0"/>
-              </a:spcBef>
-              <a:spcAft>
-                <a:spcPts val="0"/>
-              </a:spcAft>
-              <a:defRPr sz="1000">
-                <a:solidFill>
-                  <a:srgbClr val="53677A"/>
-                </a:solidFill>
-                <a:latin typeface="Arial"/>
-              </a:defRPr>
-            </a:pPr>
-            <a:r>
-              <a:t>session-4.md   ·   34</a:t>
-            </a:r>
-          </a:p>
-        </p:txBody>
-      </p:sp>
-      <p:sp>
-        <p:nvSpPr>
-          <p:cNvPr id="6" name="content:line-300:1"/>
-          <p:cNvSpPr txBox="1"/>
-          <p:nvPr/>
-        </p:nvSpPr>
-        <p:spPr>
-          <a:xfrm>
-            <a:off x="594360" y="1737360"/>
-            <a:ext cx="11003279" cy="780288"/>
-          </a:xfrm>
-          <a:prstGeom prst="rect">
-            <a:avLst/>
-          </a:prstGeom>
-          <a:noFill/>
-        </p:spPr>
-        <p:txBody>
-          <a:bodyPr wrap="none" anchor="t" lIns="88900" rIns="88900" tIns="38100" bIns="38100">
-            <a:noAutofit/>
-          </a:bodyPr>
-          <a:lstStyle/>
-          <a:p>
-            <a:pPr marL="279400" indent="-215900">
-              <a:lnSpc>
-                <a:spcPts val="2772"/>
-              </a:lnSpc>
-              <a:spcBef>
-                <a:spcPts val="0"/>
-              </a:spcBef>
-              <a:spcAft>
-                <a:spcPts val="0"/>
-              </a:spcAft>
-              <a:defRPr sz="2100">
-                <a:solidFill>
-                  <a:srgbClr val="20344A"/>
-                </a:solidFill>
-                <a:latin typeface="Arial"/>
-              </a:defRPr>
-              <a:buChar char=" "/>
-            </a:pPr>
-            <a:r>
-              <a:rPr sz="2100" b="0" i="0">
-                <a:solidFill>
-                  <a:srgbClr val="20344A"/>
-                </a:solidFill>
-                <a:latin typeface="Arial"/>
-              </a:rPr>
-              <a:t>review. Prepare for the final presentation's pass/fail </a:t>
-            </a:r>
-            <a:br/>
-            <a:r>
-              <a:rPr sz="2100" b="0" i="0">
-                <a:solidFill>
-                  <a:srgbClr val="20344A"/>
-                </a:solidFill>
-                <a:latin typeface="Arial"/>
-              </a:rPr>
-              <a:t>engineering checks.</a:t>
-            </a:r>
-          </a:p>
-        </p:txBody>
-      </p:sp>
-      <p:sp>
-        <p:nvSpPr>
-          <p:cNvPr id="7" name="content:line-301:0"/>
-          <p:cNvSpPr txBox="1"/>
-          <p:nvPr/>
-        </p:nvSpPr>
-        <p:spPr>
-          <a:xfrm>
-            <a:off x="594360" y="2581656"/>
-            <a:ext cx="11003279" cy="1132332"/>
-          </a:xfrm>
-          <a:prstGeom prst="rect">
-            <a:avLst/>
-          </a:prstGeom>
-          <a:noFill/>
-        </p:spPr>
-        <p:txBody>
-          <a:bodyPr wrap="none" anchor="t" lIns="88900" rIns="88900" tIns="38100" bIns="38100">
-            <a:noAutofit/>
-          </a:bodyPr>
-          <a:lstStyle/>
-          <a:p>
-            <a:pPr marL="279400" indent="-215900">
-              <a:lnSpc>
-                <a:spcPts val="2772"/>
-              </a:lnSpc>
-              <a:spcBef>
-                <a:spcPts val="0"/>
-              </a:spcBef>
-              <a:spcAft>
-                <a:spcPts val="0"/>
-              </a:spcAft>
-              <a:defRPr sz="2100">
-                <a:solidFill>
-                  <a:srgbClr val="20344A"/>
-                </a:solidFill>
-                <a:latin typeface="Arial"/>
-              </a:defRPr>
-              <a:buChar char="•"/>
-            </a:pPr>
-            <a:r>
-              <a:rPr sz="2100" b="0" i="0">
-                <a:solidFill>
-                  <a:srgbClr val="20344A"/>
-                </a:solidFill>
-                <a:latin typeface="Arial"/>
-              </a:rPr>
-              <a:t>This checkpoint is preparation, not a separate assessed </a:t>
-            </a:r>
-            <a:br/>
-            <a:r>
-              <a:rPr sz="2100" b="0" i="0">
-                <a:solidFill>
-                  <a:srgbClr val="20344A"/>
-                </a:solidFill>
-                <a:latin typeface="Arial"/>
-              </a:rPr>
-              <a:t>submission. Final presentation has no resubmission or </a:t>
-            </a:r>
-            <a:br/>
-            <a:r>
-              <a:rPr sz="2100" b="0" i="0">
-                <a:solidFill>
-                  <a:srgbClr val="20344A"/>
-                </a:solidFill>
-                <a:latin typeface="Arial"/>
-              </a:rPr>
-              <a:t>reassessment; see </a:t>
-            </a:r>
-            <a:r>
-              <a:rPr sz="2100" b="0" i="0">
-                <a:solidFill>
-                  <a:srgbClr val="007F82"/>
-                </a:solidFill>
-                <a:latin typeface="Arial"/>
-                <a:hlinkClick r:id="rId2"/>
-              </a:rPr>
-              <a:t>assessment policy</a:t>
-            </a:r>
-            <a:r>
-              <a:rPr sz="2100" b="0" i="0">
-                <a:solidFill>
-                  <a:srgbClr val="20344A"/>
-                </a:solidFill>
-                <a:latin typeface="Arial"/>
-              </a:rPr>
-              <a:t>.</a:t>
-            </a:r>
-          </a:p>
-        </p:txBody>
-      </p:sp>
-    </p:spTree>
-  </p:cSld>
-  <p:clrMapOvr>
-    <a:masterClrMapping/>
-  </p:clrMapOvr>
-</p:sld>
-</file>
-
-<file path=ppt/slides/slide35.xml><?xml version="1.0" encoding="utf-8"?>
-<p:sld xmlns:a="http://schemas.openxmlformats.org/drawingml/2006/main" xmlns:p="http://schemas.openxmlformats.org/presentationml/2006/main" xmlns:r="http://schemas.openxmlformats.org/officeDocument/2006/relationships">
-  <p:cSld>
-    <p:bg>
-      <p:bgPr>
-        <a:solidFill>
-          <a:srgbClr val="FAFCFD"/>
-        </a:solidFill>
-        <a:effectLst/>
-      </p:bgPr>
-    </p:bg>
-    <p:spTree>
-      <p:nvGrpSpPr>
-        <p:cNvPr id="1" name=""/>
-        <p:cNvGrpSpPr/>
-        <p:nvPr/>
-      </p:nvGrpSpPr>
-      <p:grpSpPr/>
-      <p:sp>
-        <p:nvSpPr>
-          <p:cNvPr id="2" name="accent"/>
-          <p:cNvSpPr/>
-          <p:nvPr/>
-        </p:nvSpPr>
-        <p:spPr>
-          <a:xfrm>
-            <a:off x="0" y="0"/>
-            <a:ext cx="12191999" cy="64008"/>
-          </a:xfrm>
-          <a:prstGeom prst="rect">
-            <a:avLst/>
-          </a:prstGeom>
-          <a:solidFill>
-            <a:srgbClr val="007F82"/>
-          </a:solidFill>
-          <a:ln>
-            <a:noFill/>
-          </a:ln>
-        </p:spPr>
-        <p:style>
-          <a:lnRef idx="1">
-            <a:schemeClr val="accent1"/>
-          </a:lnRef>
-          <a:fillRef idx="3">
-            <a:schemeClr val="accent1"/>
-          </a:fillRef>
-          <a:effectRef idx="2">
-            <a:schemeClr val="accent1"/>
-          </a:effectRef>
-          <a:fontRef idx="minor">
-            <a:schemeClr val="lt1"/>
-          </a:fontRef>
-        </p:style>
-        <p:txBody>
-          <a:bodyPr rtlCol="0" anchor="ctr"/>
-          <a:lstStyle/>
-          <a:p>
-            <a:pPr algn="ctr"/>
-          </a:p>
-        </p:txBody>
-      </p:sp>
-      <p:sp>
-        <p:nvSpPr>
-          <p:cNvPr id="3" name="section"/>
-          <p:cNvSpPr txBox="1"/>
-          <p:nvPr/>
-        </p:nvSpPr>
-        <p:spPr>
-          <a:xfrm>
-            <a:off x="594360" y="201168"/>
-            <a:ext cx="11003279" cy="256032"/>
-          </a:xfrm>
-          <a:prstGeom prst="rect">
-            <a:avLst/>
-          </a:prstGeom>
-          <a:noFill/>
-        </p:spPr>
-        <p:txBody>
-          <a:bodyPr wrap="none" anchor="t" lIns="88900" rIns="88900" tIns="38100" bIns="38100">
-            <a:noAutofit/>
-          </a:bodyPr>
-          <a:lstStyle/>
-          <a:p>
-            <a:pPr>
-              <a:lnSpc>
-                <a:spcPts val="1452"/>
-              </a:lnSpc>
-              <a:spcBef>
-                <a:spcPts val="0"/>
-              </a:spcBef>
-              <a:spcAft>
-                <a:spcPts val="0"/>
-              </a:spcAft>
-              <a:defRPr sz="1100">
-                <a:solidFill>
-                  <a:srgbClr val="53677A"/>
-                </a:solidFill>
-                <a:latin typeface="Arial"/>
-              </a:defRPr>
-            </a:pPr>
-            <a:r>
-              <a:t>SOURCE 23 / 23</a:t>
-            </a:r>
-          </a:p>
-        </p:txBody>
-      </p:sp>
-      <p:sp>
-        <p:nvSpPr>
-          <p:cNvPr id="4" name="title:line-305"/>
-          <p:cNvSpPr txBox="1"/>
-          <p:nvPr/>
-        </p:nvSpPr>
-        <p:spPr>
-          <a:xfrm>
-            <a:off x="594360" y="530352"/>
-            <a:ext cx="11003279" cy="1161288"/>
-          </a:xfrm>
-          <a:prstGeom prst="rect">
-            <a:avLst/>
-          </a:prstGeom>
-          <a:noFill/>
-        </p:spPr>
-        <p:txBody>
-          <a:bodyPr wrap="none" anchor="t" lIns="88900" rIns="88900" tIns="38100" bIns="38100">
-            <a:noAutofit/>
-          </a:bodyPr>
-          <a:lstStyle/>
-          <a:p>
-            <a:pPr>
-              <a:lnSpc>
-                <a:spcPts val="4000"/>
-              </a:lnSpc>
-              <a:spcBef>
-                <a:spcPts val="0"/>
-              </a:spcBef>
-              <a:spcAft>
-                <a:spcPts val="0"/>
-              </a:spcAft>
-              <a:defRPr sz="3200">
-                <a:solidFill>
-                  <a:srgbClr val="20344A"/>
-                </a:solidFill>
-                <a:latin typeface="Arial"/>
-              </a:defRPr>
-            </a:pPr>
-            <a:r>
-              <a:rPr sz="3200" b="0" i="0">
-                <a:solidFill>
-                  <a:srgbClr val="20344A"/>
-                </a:solidFill>
-                <a:latin typeface="Arial"/>
-              </a:rPr>
-              <a:t>Source map for rehearsal</a:t>
-            </a:r>
-          </a:p>
-        </p:txBody>
-      </p:sp>
-      <p:sp>
-        <p:nvSpPr>
-          <p:cNvPr id="5" name="footer"/>
-          <p:cNvSpPr txBox="1"/>
-          <p:nvPr/>
-        </p:nvSpPr>
-        <p:spPr>
-          <a:xfrm>
-            <a:off x="594360" y="6510528"/>
-            <a:ext cx="11003279" cy="219456"/>
-          </a:xfrm>
-          <a:prstGeom prst="rect">
-            <a:avLst/>
-          </a:prstGeom>
-          <a:noFill/>
-        </p:spPr>
-        <p:txBody>
-          <a:bodyPr wrap="none" anchor="t" lIns="88900" rIns="88900" tIns="38100" bIns="38100">
-            <a:noAutofit/>
-          </a:bodyPr>
-          <a:lstStyle/>
-          <a:p>
-            <a:pPr>
-              <a:lnSpc>
-                <a:spcPts val="1320"/>
-              </a:lnSpc>
-              <a:spcBef>
-                <a:spcPts val="0"/>
-              </a:spcBef>
-              <a:spcAft>
-                <a:spcPts val="0"/>
-              </a:spcAft>
-              <a:defRPr sz="1000">
-                <a:solidFill>
-                  <a:srgbClr val="53677A"/>
-                </a:solidFill>
-                <a:latin typeface="Arial"/>
-              </a:defRPr>
-            </a:pPr>
-            <a:r>
-              <a:t>session-4.md   ·   35</a:t>
-            </a:r>
-          </a:p>
-        </p:txBody>
-      </p:sp>
-      <p:sp>
-        <p:nvSpPr>
-          <p:cNvPr id="6" name="content:line-307:0"/>
+          <p:cNvPr id="6" name="content:line-297:0"/>
           <p:cNvSpPr txBox="1"/>
           <p:nvPr/>
         </p:nvSpPr>
@@ -16920,16 +16092,16 @@
                 <a:latin typeface="Arial"/>
                 <a:hlinkClick r:id="rId2"/>
               </a:rPr>
-              <a:t>Course specification</a:t>
-            </a:r>
-            <a:r>
-              <a:rPr sz="2100" b="0" i="0">
-                <a:solidFill>
-                  <a:srgbClr val="20344A"/>
-                </a:solidFill>
-                <a:latin typeface="Arial"/>
-              </a:rPr>
-              <a:t>, </a:t>
+              <a:t>Syllabus</a:t>
+            </a:r>
+            <a:r>
+              <a:rPr sz="2100" b="0" i="0">
+                <a:solidFill>
+                  <a:srgbClr val="20344A"/>
+                </a:solidFill>
+                <a:latin typeface="Arial"/>
+              </a:rPr>
+              <a:t> and </a:t>
             </a:r>
             <a:r>
               <a:rPr sz="2100" b="0" i="0">
@@ -16939,25 +16111,6 @@
                 <a:latin typeface="Arial"/>
                 <a:hlinkClick r:id="rId3"/>
               </a:rPr>
-              <a:t>syllabus</a:t>
-            </a:r>
-            <a:r>
-              <a:rPr sz="2100" b="0" i="0">
-                <a:solidFill>
-                  <a:srgbClr val="20344A"/>
-                </a:solidFill>
-                <a:latin typeface="Arial"/>
-              </a:rPr>
-              <a:t>, and </a:t>
-            </a:r>
-            <a:r>
-              <a:rPr sz="2100" b="0" i="0">
-                <a:solidFill>
-                  <a:srgbClr val="007F82"/>
-                </a:solidFill>
-                <a:latin typeface="Arial"/>
-                <a:hlinkClick r:id="rId4"/>
-              </a:rPr>
               <a:t>three-R glossary</a:t>
             </a:r>
             <a:r>
@@ -16974,7 +16127,7 @@
       </p:sp>
       <p:sp>
         <p:nvSpPr>
-          <p:cNvPr id="7" name="content:line-308:0"/>
+          <p:cNvPr id="7" name="content:line-298:0"/>
           <p:cNvSpPr txBox="1"/>
           <p:nvPr/>
         </p:nvSpPr>
@@ -17018,18 +16171,37 @@
                   <a:srgbClr val="007F82"/>
                 </a:solidFill>
                 <a:latin typeface="Arial"/>
+                <a:hlinkClick r:id="rId4"/>
+              </a:rPr>
+              <a:t>Local frontend and recovery</a:t>
+            </a:r>
+            <a:r>
+              <a:rPr sz="2100" b="0" i="0">
+                <a:solidFill>
+                  <a:srgbClr val="20344A"/>
+                </a:solidFill>
+                <a:latin typeface="Arial"/>
+              </a:rPr>
+              <a:t>, </a:t>
+            </a:r>
+            <a:r>
+              <a:rPr sz="2100" b="0" i="0">
+                <a:solidFill>
+                  <a:srgbClr val="007F82"/>
+                </a:solidFill>
+                <a:latin typeface="Arial"/>
                 <a:hlinkClick r:id="rId5"/>
               </a:rPr>
-              <a:t>Local frontend and recovery</a:t>
-            </a:r>
-            <a:r>
-              <a:rPr sz="2100" b="0" i="0">
-                <a:solidFill>
-                  <a:srgbClr val="20344A"/>
-                </a:solidFill>
-                <a:latin typeface="Arial"/>
-              </a:rPr>
-              <a:t>, </a:t>
+              <a:t>Compose operation</a:t>
+            </a:r>
+            <a:r>
+              <a:rPr sz="2100" b="0" i="0">
+                <a:solidFill>
+                  <a:srgbClr val="20344A"/>
+                </a:solidFill>
+                <a:latin typeface="Arial"/>
+              </a:rPr>
+              <a:t>, and </a:t>
             </a:r>
             <a:r>
               <a:rPr sz="2100" b="0" i="0">
@@ -17039,35 +16211,16 @@
                 <a:latin typeface="Arial"/>
                 <a:hlinkClick r:id="rId6"/>
               </a:rPr>
-              <a:t>Compose operation</a:t>
-            </a:r>
-            <a:r>
-              <a:rPr sz="2100" b="0" i="0">
-                <a:solidFill>
-                  <a:srgbClr val="20344A"/>
-                </a:solidFill>
-                <a:latin typeface="Arial"/>
-              </a:rPr>
-              <a:t>, and </a:t>
-            </a:r>
+              <a:t>output </a:t>
+            </a:r>
+            <a:br/>
             <a:r>
               <a:rPr sz="2100" b="0" i="0">
                 <a:solidFill>
                   <a:srgbClr val="007F82"/>
                 </a:solidFill>
                 <a:latin typeface="Arial"/>
-                <a:hlinkClick r:id="rId7"/>
-              </a:rPr>
-              <a:t>output </a:t>
-            </a:r>
-            <a:br/>
-            <a:r>
-              <a:rPr sz="2100" b="0" i="0">
-                <a:solidFill>
-                  <a:srgbClr val="007F82"/>
-                </a:solidFill>
-                <a:latin typeface="Arial"/>
-                <a:hlinkClick r:id="rId7"/>
+                <a:hlinkClick r:id="rId6"/>
               </a:rPr>
               <a:t>capture/comparison commands</a:t>
             </a:r>
@@ -17085,7 +16238,7 @@
       </p:sp>
       <p:sp>
         <p:nvSpPr>
-          <p:cNvPr id="8" name="content:line-309:0"/>
+          <p:cNvPr id="8" name="content:line-299:0"/>
           <p:cNvSpPr txBox="1"/>
           <p:nvPr/>
         </p:nvSpPr>
@@ -17129,18 +16282,37 @@
                   <a:srgbClr val="007F82"/>
                 </a:solidFill>
                 <a:latin typeface="Arial"/>
+                <a:hlinkClick r:id="rId7"/>
+              </a:rPr>
+              <a:t>Backend image</a:t>
+            </a:r>
+            <a:r>
+              <a:rPr sz="2100" b="0" i="0">
+                <a:solidFill>
+                  <a:srgbClr val="20344A"/>
+                </a:solidFill>
+                <a:latin typeface="Arial"/>
+              </a:rPr>
+              <a:t>, </a:t>
+            </a:r>
+            <a:r>
+              <a:rPr sz="2100" b="0" i="0">
+                <a:solidFill>
+                  <a:srgbClr val="007F82"/>
+                </a:solidFill>
+                <a:latin typeface="Arial"/>
                 <a:hlinkClick r:id="rId8"/>
               </a:rPr>
-              <a:t>Backend image</a:t>
-            </a:r>
-            <a:r>
-              <a:rPr sz="2100" b="0" i="0">
-                <a:solidFill>
-                  <a:srgbClr val="20344A"/>
-                </a:solidFill>
-                <a:latin typeface="Arial"/>
-              </a:rPr>
-              <a:t>, </a:t>
+              <a:t>frontend image</a:t>
+            </a:r>
+            <a:r>
+              <a:rPr sz="2100" b="0" i="0">
+                <a:solidFill>
+                  <a:srgbClr val="20344A"/>
+                </a:solidFill>
+                <a:latin typeface="Arial"/>
+              </a:rPr>
+              <a:t>, and </a:t>
             </a:r>
             <a:r>
               <a:rPr sz="2100" b="0" i="0">
@@ -17150,25 +16322,6 @@
                 <a:latin typeface="Arial"/>
                 <a:hlinkClick r:id="rId9"/>
               </a:rPr>
-              <a:t>frontend image</a:t>
-            </a:r>
-            <a:r>
-              <a:rPr sz="2100" b="0" i="0">
-                <a:solidFill>
-                  <a:srgbClr val="20344A"/>
-                </a:solidFill>
-                <a:latin typeface="Arial"/>
-              </a:rPr>
-              <a:t>, and </a:t>
-            </a:r>
-            <a:r>
-              <a:rPr sz="2100" b="0" i="0">
-                <a:solidFill>
-                  <a:srgbClr val="007F82"/>
-                </a:solidFill>
-                <a:latin typeface="Arial"/>
-                <a:hlinkClick r:id="rId10"/>
-              </a:rPr>
               <a:t>service configuration</a:t>
             </a:r>
             <a:r>
@@ -17185,7 +16338,7 @@
       </p:sp>
       <p:sp>
         <p:nvSpPr>
-          <p:cNvPr id="9" name="content:line-310:0"/>
+          <p:cNvPr id="9" name="content:line-300:0"/>
           <p:cNvSpPr txBox="1"/>
           <p:nvPr/>
         </p:nvSpPr>
@@ -17229,27 +16382,27 @@
                   <a:srgbClr val="007F82"/>
                 </a:solidFill>
                 <a:latin typeface="Arial"/>
+                <a:hlinkClick r:id="rId10"/>
+              </a:rPr>
+              <a:t>Synthetic input provenance</a:t>
+            </a:r>
+            <a:r>
+              <a:rPr sz="2100" b="0" i="0">
+                <a:solidFill>
+                  <a:srgbClr val="20344A"/>
+                </a:solidFill>
+                <a:latin typeface="Arial"/>
+              </a:rPr>
+              <a:t> and </a:t>
+            </a:r>
+            <a:r>
+              <a:rPr sz="2100" b="0" i="0">
+                <a:solidFill>
+                  <a:srgbClr val="007F82"/>
+                </a:solidFill>
+                <a:latin typeface="Arial"/>
                 <a:hlinkClick r:id="rId11"/>
               </a:rPr>
-              <a:t>Synthetic input provenance</a:t>
-            </a:r>
-            <a:r>
-              <a:rPr sz="2100" b="0" i="0">
-                <a:solidFill>
-                  <a:srgbClr val="20344A"/>
-                </a:solidFill>
-                <a:latin typeface="Arial"/>
-              </a:rPr>
-              <a:t> and </a:t>
-            </a:r>
-            <a:r>
-              <a:rPr sz="2100" b="0" i="0">
-                <a:solidFill>
-                  <a:srgbClr val="007F82"/>
-                </a:solidFill>
-                <a:latin typeface="Arial"/>
-                <a:hlinkClick r:id="rId12"/>
-              </a:rPr>
               <a:t>API contract</a:t>
             </a:r>
             <a:r>
@@ -17266,7 +16419,7 @@
       </p:sp>
       <p:sp>
         <p:nvSpPr>
-          <p:cNvPr id="10" name="content:line-311:0"/>
+          <p:cNvPr id="10" name="content:line-301:0"/>
           <p:cNvSpPr txBox="1"/>
           <p:nvPr/>
         </p:nvSpPr>
@@ -17310,28 +16463,9 @@
                   <a:srgbClr val="007F82"/>
                 </a:solidFill>
                 <a:latin typeface="Arial"/>
-                <a:hlinkClick r:id="rId13"/>
-              </a:rPr>
-              <a:t>Session 4 authoring ticket</a:t>
-            </a:r>
-            <a:r>
-              <a:rPr sz="2100" b="0" i="0">
-                <a:solidFill>
-                  <a:srgbClr val="20344A"/>
-                </a:solidFill>
-                <a:latin typeface="Arial"/>
-              </a:rPr>
-              <a:t> and </a:t>
-            </a:r>
-            <a:r>
-              <a:rPr sz="2100" b="0" i="0">
-                <a:solidFill>
-                  <a:srgbClr val="007F82"/>
-                </a:solidFill>
-                <a:latin typeface="Arial"/>
-                <a:hlinkClick r:id="rId14"/>
-              </a:rPr>
-              <a:t>supported slide Markdown</a:t>
+                <a:hlinkClick r:id="rId12"/>
+              </a:rPr>
+              <a:t>Supported slide Markdown</a:t>
             </a:r>
             <a:r>
               <a:rPr sz="2100" b="0" i="0">
@@ -17454,7 +16588,7 @@
               </a:defRPr>
             </a:pPr>
             <a:r>
-              <a:t>SOURCE 4 / 23</a:t>
+              <a:t>SOURCE 4 / 22</a:t>
             </a:r>
           </a:p>
         </p:txBody>
@@ -18124,7 +17258,7 @@
               </a:defRPr>
             </a:pPr>
             <a:r>
-              <a:t>SOURCE 4 / 23  ·  CONTINUED 2</a:t>
+              <a:t>SOURCE 4 / 22  ·  CONTINUED 2</a:t>
             </a:r>
           </a:p>
         </p:txBody>
@@ -18443,7 +17577,7 @@
               </a:defRPr>
             </a:pPr>
             <a:r>
-              <a:t>SOURCE 5 / 23</a:t>
+              <a:t>SOURCE 5 / 22</a:t>
             </a:r>
           </a:p>
         </p:txBody>
@@ -18973,7 +18107,7 @@
               </a:defRPr>
             </a:pPr>
             <a:r>
-              <a:t>SOURCE 6 / 23</a:t>
+              <a:t>SOURCE 6 / 22</a:t>
             </a:r>
           </a:p>
         </p:txBody>
@@ -19699,7 +18833,7 @@
               </a:defRPr>
             </a:pPr>
             <a:r>
-              <a:t>SOURCE 7 / 23</a:t>
+              <a:t>SOURCE 7 / 22</a:t>
             </a:r>
           </a:p>
         </p:txBody>
@@ -20439,7 +19573,7 @@
               </a:defRPr>
             </a:pPr>
             <a:r>
-              <a:t>SOURCE 8 / 23</a:t>
+              <a:t>SOURCE 8 / 22</a:t>
             </a:r>
           </a:p>
         </p:txBody>

</xml_diff>

<commit_message>
Remove the healthcare example and runnable code; add the Session 2 rehearsal script
Co-Authored-By: Claude Sonnet 5.5 <noreply@anthropic.com>
</commit_message>
<xml_diff>
--- a/materials/slides/session-4.pptx
+++ b/materials/slides/session-4.pptx
@@ -6398,77 +6398,6 @@
           </a:p>
         </p:txBody>
       </p:sp>
-      <p:sp>
-        <p:nvSpPr>
-          <p:cNvPr id="12" name="content:line-168:0"/>
-          <p:cNvSpPr txBox="1"/>
-          <p:nvPr/>
-        </p:nvSpPr>
-        <p:spPr>
-          <a:xfrm>
-            <a:off x="594360" y="5747004"/>
-            <a:ext cx="11003279" cy="428244"/>
-          </a:xfrm>
-          <a:prstGeom prst="rect">
-            <a:avLst/>
-          </a:prstGeom>
-          <a:noFill/>
-        </p:spPr>
-        <p:txBody>
-          <a:bodyPr wrap="none" anchor="t" lIns="88900" rIns="88900" tIns="38100" bIns="38100">
-            <a:noAutofit/>
-          </a:bodyPr>
-          <a:lstStyle/>
-          <a:p>
-            <a:pPr marL="279400" indent="-215900">
-              <a:lnSpc>
-                <a:spcPts val="2772"/>
-              </a:lnSpc>
-              <a:spcBef>
-                <a:spcPts val="0"/>
-              </a:spcBef>
-              <a:spcAft>
-                <a:spcPts val="0"/>
-              </a:spcAft>
-              <a:defRPr sz="2100">
-                <a:solidFill>
-                  <a:srgbClr val="20344A"/>
-                </a:solidFill>
-                <a:latin typeface="Arial"/>
-              </a:defRPr>
-              <a:buChar char="•"/>
-            </a:pPr>
-            <a:r>
-              <a:rPr sz="2100" b="0" i="0">
-                <a:solidFill>
-                  <a:srgbClr val="20344A"/>
-                </a:solidFill>
-                <a:latin typeface="Arial"/>
-              </a:rPr>
-              <a:t>See </a:t>
-            </a:r>
-            <a:r>
-              <a:rPr sz="2100" b="0" i="0">
-                <a:solidFill>
-                  <a:srgbClr val="007F82"/>
-                </a:solidFill>
-                <a:latin typeface="Arial"/>
-                <a:hlinkClick r:id="rId2"/>
-              </a:rPr>
-              <a:t>address and troubleshooting guide</a:t>
-            </a:r>
-            <a:r>
-              <a:rPr sz="2100" b="0" i="0">
-                <a:solidFill>
-                  <a:srgbClr val="20344A"/>
-                </a:solidFill>
-                <a:latin typeface="Arial"/>
-              </a:rPr>
-              <a:t>.</a:t>
-            </a:r>
-          </a:p>
-        </p:txBody>
-      </p:sp>
     </p:spTree>
   </p:cSld>
   <p:clrMapOvr>
@@ -6585,7 +6514,7 @@
       </p:sp>
       <p:sp>
         <p:nvSpPr>
-          <p:cNvPr id="4" name="title:line-172"/>
+          <p:cNvPr id="4" name="title:line-171"/>
           <p:cNvSpPr txBox="1"/>
           <p:nvPr/>
         </p:nvSpPr>
@@ -6681,7 +6610,7 @@
       </p:sp>
       <p:sp>
         <p:nvSpPr>
-          <p:cNvPr id="6" name="content:line-174:0"/>
+          <p:cNvPr id="6" name="content:line-173:0"/>
           <p:cNvSpPr txBox="1"/>
           <p:nvPr/>
         </p:nvSpPr>
@@ -6770,7 +6699,7 @@
       </p:sp>
       <p:sp>
         <p:nvSpPr>
-          <p:cNvPr id="7" name="content:line-175:0"/>
+          <p:cNvPr id="7" name="content:line-174:0"/>
           <p:cNvSpPr txBox="1"/>
           <p:nvPr/>
         </p:nvSpPr>
@@ -6832,7 +6761,7 @@
       </p:sp>
       <p:sp>
         <p:nvSpPr>
-          <p:cNvPr id="8" name="content:line-176:0"/>
+          <p:cNvPr id="8" name="content:line-175:0"/>
           <p:cNvSpPr txBox="1"/>
           <p:nvPr/>
         </p:nvSpPr>
@@ -6930,7 +6859,7 @@
       </p:sp>
       <p:sp>
         <p:nvSpPr>
-          <p:cNvPr id="9" name="content:line-177:0"/>
+          <p:cNvPr id="9" name="content:line-176:0"/>
           <p:cNvSpPr txBox="1"/>
           <p:nvPr/>
         </p:nvSpPr>
@@ -6992,7 +6921,7 @@
       </p:sp>
       <p:sp>
         <p:nvSpPr>
-          <p:cNvPr id="10" name="content:line-178:0"/>
+          <p:cNvPr id="10" name="content:line-177:0"/>
           <p:cNvSpPr txBox="1"/>
           <p:nvPr/>
         </p:nvSpPr>
@@ -7158,7 +7087,7 @@
       </p:sp>
       <p:sp>
         <p:nvSpPr>
-          <p:cNvPr id="4" name="title:line-182"/>
+          <p:cNvPr id="4" name="title:line-181"/>
           <p:cNvSpPr txBox="1"/>
           <p:nvPr/>
         </p:nvSpPr>
@@ -7254,7 +7183,7 @@
       </p:sp>
       <p:sp>
         <p:nvSpPr>
-          <p:cNvPr id="6" name="content:line-184:0"/>
+          <p:cNvPr id="6" name="content:line-183:0"/>
           <p:cNvSpPr txBox="1"/>
           <p:nvPr/>
         </p:nvSpPr>
@@ -7323,7 +7252,7 @@
       </p:sp>
       <p:sp>
         <p:nvSpPr>
-          <p:cNvPr id="7" name="content:line-187:0"/>
+          <p:cNvPr id="7" name="content:line-186:0"/>
           <p:cNvSpPr txBox="1"/>
           <p:nvPr/>
         </p:nvSpPr>
@@ -7376,7 +7305,7 @@
       </p:sp>
       <p:sp>
         <p:nvSpPr>
-          <p:cNvPr id="8" name="content:line-188:0"/>
+          <p:cNvPr id="8" name="content:line-187:0"/>
           <p:cNvSpPr txBox="1"/>
           <p:nvPr/>
         </p:nvSpPr>
@@ -7429,7 +7358,7 @@
       </p:sp>
       <p:sp>
         <p:nvSpPr>
-          <p:cNvPr id="9" name="content:line-191:0"/>
+          <p:cNvPr id="9" name="content:line-190:0"/>
           <p:cNvSpPr txBox="1"/>
           <p:nvPr/>
         </p:nvSpPr>
@@ -7480,7 +7409,7 @@
       </p:sp>
       <p:sp>
         <p:nvSpPr>
-          <p:cNvPr id="10" name="content:line-194:0"/>
+          <p:cNvPr id="10" name="content:line-193:0"/>
           <p:cNvSpPr txBox="1"/>
           <p:nvPr/>
         </p:nvSpPr>
@@ -7533,7 +7462,7 @@
       </p:sp>
       <p:sp>
         <p:nvSpPr>
-          <p:cNvPr id="11" name="content:line-197:0"/>
+          <p:cNvPr id="11" name="content:line-196:0"/>
           <p:cNvSpPr txBox="1"/>
           <p:nvPr/>
         </p:nvSpPr>
@@ -7698,7 +7627,7 @@
       </p:sp>
       <p:sp>
         <p:nvSpPr>
-          <p:cNvPr id="4" name="title:line-201"/>
+          <p:cNvPr id="4" name="title:line-200"/>
           <p:cNvSpPr txBox="1"/>
           <p:nvPr/>
         </p:nvSpPr>
@@ -7794,7 +7723,7 @@
       </p:sp>
       <p:sp>
         <p:nvSpPr>
-          <p:cNvPr id="6" name="content:line-204:0"/>
+          <p:cNvPr id="6" name="content:line-203:0"/>
           <p:cNvSpPr txBox="1"/>
           <p:nvPr/>
         </p:nvSpPr>
@@ -7847,7 +7776,7 @@
       </p:sp>
       <p:sp>
         <p:nvSpPr>
-          <p:cNvPr id="7" name="content:line-207:0"/>
+          <p:cNvPr id="7" name="content:line-206:0"/>
           <p:cNvSpPr txBox="1"/>
           <p:nvPr/>
         </p:nvSpPr>
@@ -7936,7 +7865,7 @@
       </p:sp>
       <p:sp>
         <p:nvSpPr>
-          <p:cNvPr id="8" name="content:line-208:0"/>
+          <p:cNvPr id="8" name="content:line-207:0"/>
           <p:cNvSpPr txBox="1"/>
           <p:nvPr/>
         </p:nvSpPr>
@@ -8006,7 +7935,7 @@
       </p:sp>
       <p:sp>
         <p:nvSpPr>
-          <p:cNvPr id="9" name="content:line-209:0"/>
+          <p:cNvPr id="9" name="content:line-208:0"/>
           <p:cNvSpPr txBox="1"/>
           <p:nvPr/>
         </p:nvSpPr>
@@ -8208,7 +8137,7 @@
       </p:sp>
       <p:sp>
         <p:nvSpPr>
-          <p:cNvPr id="4" name="title:line-213"/>
+          <p:cNvPr id="4" name="title:line-212"/>
           <p:cNvSpPr txBox="1"/>
           <p:nvPr/>
         </p:nvSpPr>
@@ -8304,7 +8233,7 @@
       </p:sp>
       <p:sp>
         <p:nvSpPr>
-          <p:cNvPr id="6" name="content:line-215:0"/>
+          <p:cNvPr id="6" name="content:line-214:0"/>
           <p:cNvSpPr txBox="1"/>
           <p:nvPr/>
         </p:nvSpPr>
@@ -8410,7 +8339,7 @@
       </p:sp>
       <p:sp>
         <p:nvSpPr>
-          <p:cNvPr id="7" name="content:line-218:0"/>
+          <p:cNvPr id="7" name="content:line-217:0"/>
           <p:cNvSpPr txBox="1"/>
           <p:nvPr/>
         </p:nvSpPr>
@@ -8463,7 +8392,7 @@
       </p:sp>
       <p:sp>
         <p:nvSpPr>
-          <p:cNvPr id="8" name="content:line-221:0"/>
+          <p:cNvPr id="8" name="content:line-220:0"/>
           <p:cNvSpPr txBox="1"/>
           <p:nvPr/>
         </p:nvSpPr>
@@ -8524,7 +8453,7 @@
       </p:sp>
       <p:sp>
         <p:nvSpPr>
-          <p:cNvPr id="9" name="content:line-223:0"/>
+          <p:cNvPr id="9" name="content:line-222:0"/>
           <p:cNvSpPr txBox="1"/>
           <p:nvPr/>
         </p:nvSpPr>
@@ -8576,7 +8505,7 @@
       </p:sp>
       <p:sp>
         <p:nvSpPr>
-          <p:cNvPr id="10" name="content:line-224:0"/>
+          <p:cNvPr id="10" name="content:line-223:0"/>
           <p:cNvSpPr txBox="1"/>
           <p:nvPr/>
         </p:nvSpPr>
@@ -8628,7 +8557,7 @@
       </p:sp>
       <p:sp>
         <p:nvSpPr>
-          <p:cNvPr id="11" name="content:line-225:0"/>
+          <p:cNvPr id="11" name="content:line-224:0"/>
           <p:cNvSpPr txBox="1"/>
           <p:nvPr/>
         </p:nvSpPr>
@@ -8822,7 +8751,7 @@
       </p:sp>
       <p:sp>
         <p:nvSpPr>
-          <p:cNvPr id="4" name="title:line-229"/>
+          <p:cNvPr id="4" name="title:line-228"/>
           <p:cNvSpPr txBox="1"/>
           <p:nvPr/>
         </p:nvSpPr>
@@ -8918,7 +8847,7 @@
       </p:sp>
       <p:sp>
         <p:nvSpPr>
-          <p:cNvPr id="6" name="content:line-231:0"/>
+          <p:cNvPr id="6" name="content:line-230:0"/>
           <p:cNvSpPr txBox="1"/>
           <p:nvPr/>
         </p:nvSpPr>
@@ -8980,7 +8909,7 @@
       </p:sp>
       <p:sp>
         <p:nvSpPr>
-          <p:cNvPr id="7" name="content:line-232:0"/>
+          <p:cNvPr id="7" name="content:line-231:0"/>
           <p:cNvSpPr txBox="1"/>
           <p:nvPr/>
         </p:nvSpPr>
@@ -9042,7 +8971,7 @@
       </p:sp>
       <p:sp>
         <p:nvSpPr>
-          <p:cNvPr id="8" name="content:line-233:0"/>
+          <p:cNvPr id="8" name="content:line-232:0"/>
           <p:cNvSpPr txBox="1"/>
           <p:nvPr/>
         </p:nvSpPr>
@@ -9104,7 +9033,7 @@
       </p:sp>
       <p:sp>
         <p:nvSpPr>
-          <p:cNvPr id="9" name="content:line-234:0"/>
+          <p:cNvPr id="9" name="content:line-233:0"/>
           <p:cNvSpPr txBox="1"/>
           <p:nvPr/>
         </p:nvSpPr>
@@ -9166,7 +9095,7 @@
       </p:sp>
       <p:sp>
         <p:nvSpPr>
-          <p:cNvPr id="10" name="content:line-235:0"/>
+          <p:cNvPr id="10" name="content:line-234:0"/>
           <p:cNvSpPr txBox="1"/>
           <p:nvPr/>
         </p:nvSpPr>
@@ -9892,7 +9821,7 @@
       </p:sp>
       <p:sp>
         <p:nvSpPr>
-          <p:cNvPr id="4" name="title:line-239"/>
+          <p:cNvPr id="4" name="title:line-238"/>
           <p:cNvSpPr txBox="1"/>
           <p:nvPr/>
         </p:nvSpPr>
@@ -9998,7 +9927,7 @@
       </p:sp>
       <p:sp>
         <p:nvSpPr>
-          <p:cNvPr id="6" name="content:line-241:0"/>
+          <p:cNvPr id="6" name="content:line-240:0"/>
           <p:cNvSpPr txBox="1"/>
           <p:nvPr/>
         </p:nvSpPr>
@@ -10049,7 +9978,7 @@
       </p:sp>
       <p:sp>
         <p:nvSpPr>
-          <p:cNvPr id="7" name="content:line-243:0"/>
+          <p:cNvPr id="7" name="content:line-242:0"/>
           <p:cNvSpPr txBox="1"/>
           <p:nvPr/>
         </p:nvSpPr>
@@ -10101,7 +10030,7 @@
       </p:sp>
       <p:sp>
         <p:nvSpPr>
-          <p:cNvPr id="8" name="content:line-244:0"/>
+          <p:cNvPr id="8" name="content:line-243:0"/>
           <p:cNvSpPr txBox="1"/>
           <p:nvPr/>
         </p:nvSpPr>
@@ -10163,7 +10092,7 @@
       </p:sp>
       <p:sp>
         <p:nvSpPr>
-          <p:cNvPr id="9" name="content:line-245:0"/>
+          <p:cNvPr id="9" name="content:line-244:0"/>
           <p:cNvSpPr txBox="1"/>
           <p:nvPr/>
         </p:nvSpPr>
@@ -10243,7 +10172,7 @@
       </p:sp>
       <p:sp>
         <p:nvSpPr>
-          <p:cNvPr id="10" name="content:line-246:0"/>
+          <p:cNvPr id="10" name="content:line-245:0"/>
           <p:cNvSpPr txBox="1"/>
           <p:nvPr/>
         </p:nvSpPr>
@@ -10305,7 +10234,7 @@
       </p:sp>
       <p:sp>
         <p:nvSpPr>
-          <p:cNvPr id="11" name="content:line-248:0"/>
+          <p:cNvPr id="11" name="content:line-247:0"/>
           <p:cNvSpPr txBox="1"/>
           <p:nvPr/>
         </p:nvSpPr>
@@ -10470,7 +10399,7 @@
       </p:sp>
       <p:sp>
         <p:nvSpPr>
-          <p:cNvPr id="4" name="title:line-252"/>
+          <p:cNvPr id="4" name="title:line-251"/>
           <p:cNvSpPr txBox="1"/>
           <p:nvPr/>
         </p:nvSpPr>
@@ -10566,7 +10495,7 @@
       </p:sp>
       <p:sp>
         <p:nvSpPr>
-          <p:cNvPr id="6" name="content:line-254:0"/>
+          <p:cNvPr id="6" name="content:line-253:0"/>
           <p:cNvSpPr txBox="1"/>
           <p:nvPr/>
         </p:nvSpPr>
@@ -10646,7 +10575,7 @@
       </p:sp>
       <p:sp>
         <p:nvSpPr>
-          <p:cNvPr id="7" name="content:line-255:0"/>
+          <p:cNvPr id="7" name="content:line-254:0"/>
           <p:cNvSpPr txBox="1"/>
           <p:nvPr/>
         </p:nvSpPr>
@@ -10744,7 +10673,7 @@
       </p:sp>
       <p:sp>
         <p:nvSpPr>
-          <p:cNvPr id="8" name="content:line-256:0"/>
+          <p:cNvPr id="8" name="content:line-255:0"/>
           <p:cNvSpPr txBox="1"/>
           <p:nvPr/>
         </p:nvSpPr>
@@ -10806,7 +10735,7 @@
       </p:sp>
       <p:sp>
         <p:nvSpPr>
-          <p:cNvPr id="9" name="content:line-257:0"/>
+          <p:cNvPr id="9" name="content:line-256:0"/>
           <p:cNvSpPr txBox="1"/>
           <p:nvPr/>
         </p:nvSpPr>
@@ -10858,7 +10787,7 @@
       </p:sp>
       <p:sp>
         <p:nvSpPr>
-          <p:cNvPr id="10" name="content:line-259:0"/>
+          <p:cNvPr id="10" name="content:line-258:0"/>
           <p:cNvSpPr txBox="1"/>
           <p:nvPr/>
         </p:nvSpPr>
@@ -11042,7 +10971,7 @@
       </p:sp>
       <p:sp>
         <p:nvSpPr>
-          <p:cNvPr id="4" name="title:line-263"/>
+          <p:cNvPr id="4" name="title:line-262"/>
           <p:cNvSpPr txBox="1"/>
           <p:nvPr/>
         </p:nvSpPr>
@@ -11138,7 +11067,7 @@
       </p:sp>
       <p:sp>
         <p:nvSpPr>
-          <p:cNvPr id="6" name="content:line-265:0"/>
+          <p:cNvPr id="6" name="content:line-264:0"/>
           <p:cNvSpPr txBox="1"/>
           <p:nvPr/>
         </p:nvSpPr>
@@ -11199,7 +11128,7 @@
       </p:sp>
       <p:sp>
         <p:nvSpPr>
-          <p:cNvPr id="7" name="content:line-267:0"/>
+          <p:cNvPr id="7" name="content:line-266:0"/>
           <p:cNvSpPr txBox="1"/>
           <p:nvPr/>
         </p:nvSpPr>
@@ -11261,7 +11190,7 @@
       </p:sp>
       <p:sp>
         <p:nvSpPr>
-          <p:cNvPr id="8" name="content:line-268:0"/>
+          <p:cNvPr id="8" name="content:line-267:0"/>
           <p:cNvSpPr txBox="1"/>
           <p:nvPr/>
         </p:nvSpPr>
@@ -11323,7 +11252,7 @@
       </p:sp>
       <p:sp>
         <p:nvSpPr>
-          <p:cNvPr id="9" name="content:line-269:0"/>
+          <p:cNvPr id="9" name="content:line-268:0"/>
           <p:cNvSpPr txBox="1"/>
           <p:nvPr/>
         </p:nvSpPr>
@@ -11375,7 +11304,7 @@
       </p:sp>
       <p:sp>
         <p:nvSpPr>
-          <p:cNvPr id="10" name="content:line-271:0"/>
+          <p:cNvPr id="10" name="content:line-270:0"/>
           <p:cNvSpPr txBox="1"/>
           <p:nvPr/>
         </p:nvSpPr>

</xml_diff>